<commit_message>
updated references and visualization after third  peer review by different authors Henry Asantee
</commit_message>
<xml_diff>
--- a/final_presentation.pptx
+++ b/final_presentation.pptx
@@ -4,20 +4,19 @@
   <p:sldMasterIdLst>
     <p:sldMasterId id="2147483648" r:id="rId1"/>
   </p:sldMasterIdLst>
-  <p:notesMasterIdLst>
-    <p:notesMasterId r:id="rId12"/>
-  </p:notesMasterIdLst>
   <p:sldIdLst>
-    <p:sldId id="256" r:id="rId2"/>
-    <p:sldId id="257" r:id="rId3"/>
-    <p:sldId id="258" r:id="rId4"/>
-    <p:sldId id="259" r:id="rId5"/>
-    <p:sldId id="260" r:id="rId6"/>
-    <p:sldId id="261" r:id="rId7"/>
-    <p:sldId id="262" r:id="rId8"/>
-    <p:sldId id="263" r:id="rId9"/>
-    <p:sldId id="264" r:id="rId10"/>
-    <p:sldId id="265" r:id="rId11"/>
+    <p:sldId id="256" r:id="rId7"/>
+    <p:sldId id="257" r:id="rId9"/>
+    <p:sldId id="258" r:id="rId10"/>
+    <p:sldId id="259" r:id="rId11"/>
+    <p:sldId id="260" r:id="rId12"/>
+    <p:sldId id="261" r:id="rId13"/>
+    <p:sldId id="262" r:id="rId14"/>
+    <p:sldId id="263" r:id="rId15"/>
+    <p:sldId id="264" r:id="rId16"/>
+    <p:sldId id="265" r:id="rId17"/>
+    <p:sldId id="266" r:id="rId18"/>
+    <p:sldId id="267" r:id="rId19"/>
   </p:sldIdLst>
   <p:sldSz cx="9144000" cy="6858000" type="screen4x3"/>
   <p:notesSz cx="6858000" cy="9144000"/>
@@ -116,27 +115,11 @@
       </a:defRPr>
     </a:lvl9pPr>
   </p:defaultTextStyle>
-  <p:extLst>
-    <p:ext uri="{EFAFB233-063F-42B5-8137-9DF3F51BA10A}">
-      <p15:sldGuideLst xmlns:p15="http://schemas.microsoft.com/office/powerpoint/2012/main">
-        <p15:guide id="1" orient="horz" pos="2160">
-          <p15:clr>
-            <a:srgbClr val="A4A3A4"/>
-          </p15:clr>
-        </p15:guide>
-        <p15:guide id="2" pos="2880">
-          <p15:clr>
-            <a:srgbClr val="A4A3A4"/>
-          </p15:clr>
-        </p15:guide>
-      </p15:sldGuideLst>
-    </p:ext>
-  </p:extLst>
 </p:presentation>
 </file>
 
 <file path=ppt/notesMasters/notesMaster1.xml><?xml version="1.0" encoding="utf-8"?>
-<p:notesMaster xmlns:a="http://schemas.openxmlformats.org/drawingml/2006/main" xmlns:r="http://schemas.openxmlformats.org/officeDocument/2006/relationships" xmlns:p="http://schemas.openxmlformats.org/presentationml/2006/main">
+<p:notesMaster xmlns:a="http://schemas.openxmlformats.org/drawingml/2006/main" xmlns:p="http://schemas.openxmlformats.org/presentationml/2006/main" xmlns:r="http://schemas.openxmlformats.org/officeDocument/2006/relationships">
   <p:cSld>
     <p:bg>
       <p:bgRef idx="1001">
@@ -157,16 +140,241 @@
           <a:chExt cx="0" cy="0"/>
         </a:xfrm>
       </p:grpSpPr>
+      <p:sp>
+        <p:nvSpPr>
+          <p:cNvPr id="2" name="Header Placeholder 1"/>
+          <p:cNvSpPr>
+            <a:spLocks noGrp="1"/>
+          </p:cNvSpPr>
+          <p:nvPr>
+            <p:ph type="hdr" sz="quarter"/>
+          </p:nvPr>
+        </p:nvSpPr>
+        <p:spPr>
+          <a:xfrm>
+            <a:off x="0" y="0"/>
+            <a:ext cx="2971800" cy="457200"/>
+          </a:xfrm>
+          <a:prstGeom prst="rect">
+            <a:avLst/>
+          </a:prstGeom>
+        </p:spPr>
+        <p:txBody>
+          <a:bodyPr vert="horz" lIns="91440" tIns="45720" rIns="91440" bIns="45720" rtlCol="0"/>
+          <a:lstStyle>
+            <a:lvl1pPr algn="l">
+              <a:defRPr sz="1200"/>
+            </a:lvl1pPr>
+          </a:lstStyle>
+          <a:p>
+            <a:endParaRPr lang="en-US"/>
+          </a:p>
+        </p:txBody>
+      </p:sp>
+      <p:sp>
+        <p:nvSpPr>
+          <p:cNvPr id="3" name="Date Placeholder 2"/>
+          <p:cNvSpPr>
+            <a:spLocks noGrp="1"/>
+          </p:cNvSpPr>
+          <p:nvPr>
+            <p:ph type="dt" idx="1"/>
+          </p:nvPr>
+        </p:nvSpPr>
+        <p:spPr>
+          <a:xfrm>
+            <a:off x="3884613" y="0"/>
+            <a:ext cx="2971800" cy="457200"/>
+          </a:xfrm>
+          <a:prstGeom prst="rect">
+            <a:avLst/>
+          </a:prstGeom>
+        </p:spPr>
+        <p:txBody>
+          <a:bodyPr vert="horz" lIns="91440" tIns="45720" rIns="91440" bIns="45720" rtlCol="0"/>
+          <a:lstStyle>
+            <a:lvl1pPr algn="r">
+              <a:defRPr sz="1200"/>
+            </a:lvl1pPr>
+          </a:lstStyle>
+          <a:p>
+            <a:fld id="{0F89C1C7-3DCD-1040-A9CF-14679D8B5DDD}" type="datetimeFigureOut">
+              <a:rPr lang="en-US" smtClean="0"/>
+              <a:t>10/17/16</a:t>
+            </a:fld>
+            <a:endParaRPr lang="en-US"/>
+          </a:p>
+        </p:txBody>
+      </p:sp>
+      <p:sp>
+        <p:nvSpPr>
+          <p:cNvPr id="4" name="Slide Image Placeholder 3"/>
+          <p:cNvSpPr>
+            <a:spLocks noGrp="1" noRot="1" noChangeAspect="1"/>
+          </p:cNvSpPr>
+          <p:nvPr>
+            <p:ph type="sldImg" idx="2"/>
+          </p:nvPr>
+        </p:nvSpPr>
+        <p:spPr>
+          <a:xfrm>
+            <a:off x="1143000" y="685800"/>
+            <a:ext cx="4572000" cy="3429000"/>
+          </a:xfrm>
+          <a:prstGeom prst="rect">
+            <a:avLst/>
+          </a:prstGeom>
+          <a:noFill/>
+          <a:ln w="12700">
+            <a:solidFill>
+              <a:prstClr val="black"/>
+            </a:solidFill>
+          </a:ln>
+        </p:spPr>
+        <p:txBody>
+          <a:bodyPr vert="horz" lIns="91440" tIns="45720" rIns="91440" bIns="45720" rtlCol="0" anchor="ctr"/>
+          <a:lstStyle/>
+          <a:p>
+            <a:endParaRPr lang="en-US"/>
+          </a:p>
+        </p:txBody>
+      </p:sp>
+      <p:sp>
+        <p:nvSpPr>
+          <p:cNvPr id="5" name="Notes Placeholder 4"/>
+          <p:cNvSpPr>
+            <a:spLocks noGrp="1"/>
+          </p:cNvSpPr>
+          <p:nvPr>
+            <p:ph type="body" sz="quarter" idx="3"/>
+          </p:nvPr>
+        </p:nvSpPr>
+        <p:spPr>
+          <a:xfrm>
+            <a:off x="685800" y="4343400"/>
+            <a:ext cx="5486400" cy="4114800"/>
+          </a:xfrm>
+          <a:prstGeom prst="rect">
+            <a:avLst/>
+          </a:prstGeom>
+        </p:spPr>
+        <p:txBody>
+          <a:bodyPr vert="horz" lIns="91440" tIns="45720" rIns="91440" bIns="45720" rtlCol="0"/>
+          <a:lstStyle/>
+          <a:p>
+            <a:pPr lvl="0"/>
+            <a:r>
+              <a:rPr lang="en-US" smtClean="0"/>
+              <a:t>Click to edit Master text styles</a:t>
+            </a:r>
+          </a:p>
+          <a:p>
+            <a:pPr lvl="1"/>
+            <a:r>
+              <a:rPr lang="en-US" smtClean="0"/>
+              <a:t>Second level</a:t>
+            </a:r>
+          </a:p>
+          <a:p>
+            <a:pPr lvl="2"/>
+            <a:r>
+              <a:rPr lang="en-US" smtClean="0"/>
+              <a:t>Third level</a:t>
+            </a:r>
+          </a:p>
+          <a:p>
+            <a:pPr lvl="3"/>
+            <a:r>
+              <a:rPr lang="en-US" smtClean="0"/>
+              <a:t>Fourth level</a:t>
+            </a:r>
+          </a:p>
+          <a:p>
+            <a:pPr lvl="4"/>
+            <a:r>
+              <a:rPr lang="en-US" smtClean="0"/>
+              <a:t>Fifth level</a:t>
+            </a:r>
+            <a:endParaRPr lang="en-US"/>
+          </a:p>
+        </p:txBody>
+      </p:sp>
+      <p:sp>
+        <p:nvSpPr>
+          <p:cNvPr id="6" name="Footer Placeholder 5"/>
+          <p:cNvSpPr>
+            <a:spLocks noGrp="1"/>
+          </p:cNvSpPr>
+          <p:nvPr>
+            <p:ph type="ftr" sz="quarter" idx="4"/>
+          </p:nvPr>
+        </p:nvSpPr>
+        <p:spPr>
+          <a:xfrm>
+            <a:off x="0" y="8685213"/>
+            <a:ext cx="2971800" cy="457200"/>
+          </a:xfrm>
+          <a:prstGeom prst="rect">
+            <a:avLst/>
+          </a:prstGeom>
+        </p:spPr>
+        <p:txBody>
+          <a:bodyPr vert="horz" lIns="91440" tIns="45720" rIns="91440" bIns="45720" rtlCol="0" anchor="b"/>
+          <a:lstStyle>
+            <a:lvl1pPr algn="l">
+              <a:defRPr sz="1200"/>
+            </a:lvl1pPr>
+          </a:lstStyle>
+          <a:p>
+            <a:endParaRPr lang="en-US"/>
+          </a:p>
+        </p:txBody>
+      </p:sp>
+      <p:sp>
+        <p:nvSpPr>
+          <p:cNvPr id="7" name="Slide Number Placeholder 6"/>
+          <p:cNvSpPr>
+            <a:spLocks noGrp="1"/>
+          </p:cNvSpPr>
+          <p:nvPr>
+            <p:ph type="sldNum" sz="quarter" idx="5"/>
+          </p:nvPr>
+        </p:nvSpPr>
+        <p:spPr>
+          <a:xfrm>
+            <a:off x="3884613" y="8685213"/>
+            <a:ext cx="2971800" cy="457200"/>
+          </a:xfrm>
+          <a:prstGeom prst="rect">
+            <a:avLst/>
+          </a:prstGeom>
+        </p:spPr>
+        <p:txBody>
+          <a:bodyPr vert="horz" lIns="91440" tIns="45720" rIns="91440" bIns="45720" rtlCol="0" anchor="b"/>
+          <a:lstStyle>
+            <a:lvl1pPr algn="r">
+              <a:defRPr sz="1200"/>
+            </a:lvl1pPr>
+          </a:lstStyle>
+          <a:p>
+            <a:fld id="{BB5E49A5-4136-284D-997B-48E1D791AD67}" type="slidenum">
+              <a:rPr lang="en-US" smtClean="0"/>
+              <a:t>‹#›</a:t>
+            </a:fld>
+            <a:endParaRPr lang="en-US"/>
+          </a:p>
+        </p:txBody>
+      </p:sp>
     </p:spTree>
     <p:extLst>
       <p:ext uri="{BB962C8B-B14F-4D97-AF65-F5344CB8AC3E}">
-        <p14:creationId xmlns:p14="http://schemas.microsoft.com/office/powerpoint/2010/main" val="321091240"/>
+        <p14:creationId xmlns:p14="http://schemas.microsoft.com/office/powerpoint/2010/main" val="2623252185"/>
       </p:ext>
     </p:extLst>
   </p:cSld>
   <p:clrMap bg1="lt1" tx1="dk1" bg2="lt2" tx2="dk2" accent1="accent1" accent2="accent2" accent3="accent3" accent4="accent4" accent5="accent5" accent6="accent6" hlink="hlink" folHlink="folHlink"/>
   <p:notesStyle>
-    <a:lvl1pPr marL="0" algn="l" defTabSz="914400" rtl="0" eaLnBrk="1" latinLnBrk="0" hangingPunct="1">
+    <a:lvl1pPr marL="0" algn="l" defTabSz="457200" rtl="0" eaLnBrk="1" latinLnBrk="0" hangingPunct="1">
       <a:defRPr sz="1200" kern="1200">
         <a:solidFill>
           <a:schemeClr val="tx1"/>
@@ -176,7 +384,7 @@
         <a:cs typeface="+mn-cs"/>
       </a:defRPr>
     </a:lvl1pPr>
-    <a:lvl2pPr marL="457200" algn="l" defTabSz="914400" rtl="0" eaLnBrk="1" latinLnBrk="0" hangingPunct="1">
+    <a:lvl2pPr marL="457200" algn="l" defTabSz="457200" rtl="0" eaLnBrk="1" latinLnBrk="0" hangingPunct="1">
       <a:defRPr sz="1200" kern="1200">
         <a:solidFill>
           <a:schemeClr val="tx1"/>
@@ -186,7 +394,7 @@
         <a:cs typeface="+mn-cs"/>
       </a:defRPr>
     </a:lvl2pPr>
-    <a:lvl3pPr marL="914400" algn="l" defTabSz="914400" rtl="0" eaLnBrk="1" latinLnBrk="0" hangingPunct="1">
+    <a:lvl3pPr marL="914400" algn="l" defTabSz="457200" rtl="0" eaLnBrk="1" latinLnBrk="0" hangingPunct="1">
       <a:defRPr sz="1200" kern="1200">
         <a:solidFill>
           <a:schemeClr val="tx1"/>
@@ -196,7 +404,7 @@
         <a:cs typeface="+mn-cs"/>
       </a:defRPr>
     </a:lvl3pPr>
-    <a:lvl4pPr marL="1371600" algn="l" defTabSz="914400" rtl="0" eaLnBrk="1" latinLnBrk="0" hangingPunct="1">
+    <a:lvl4pPr marL="1371600" algn="l" defTabSz="457200" rtl="0" eaLnBrk="1" latinLnBrk="0" hangingPunct="1">
       <a:defRPr sz="1200" kern="1200">
         <a:solidFill>
           <a:schemeClr val="tx1"/>
@@ -206,7 +414,7 @@
         <a:cs typeface="+mn-cs"/>
       </a:defRPr>
     </a:lvl4pPr>
-    <a:lvl5pPr marL="1828800" algn="l" defTabSz="914400" rtl="0" eaLnBrk="1" latinLnBrk="0" hangingPunct="1">
+    <a:lvl5pPr marL="1828800" algn="l" defTabSz="457200" rtl="0" eaLnBrk="1" latinLnBrk="0" hangingPunct="1">
       <a:defRPr sz="1200" kern="1200">
         <a:solidFill>
           <a:schemeClr val="tx1"/>
@@ -216,7 +424,7 @@
         <a:cs typeface="+mn-cs"/>
       </a:defRPr>
     </a:lvl5pPr>
-    <a:lvl6pPr marL="2286000" algn="l" defTabSz="914400" rtl="0" eaLnBrk="1" latinLnBrk="0" hangingPunct="1">
+    <a:lvl6pPr marL="2286000" algn="l" defTabSz="457200" rtl="0" eaLnBrk="1" latinLnBrk="0" hangingPunct="1">
       <a:defRPr sz="1200" kern="1200">
         <a:solidFill>
           <a:schemeClr val="tx1"/>
@@ -226,7 +434,7 @@
         <a:cs typeface="+mn-cs"/>
       </a:defRPr>
     </a:lvl6pPr>
-    <a:lvl7pPr marL="2743200" algn="l" defTabSz="914400" rtl="0" eaLnBrk="1" latinLnBrk="0" hangingPunct="1">
+    <a:lvl7pPr marL="2743200" algn="l" defTabSz="457200" rtl="0" eaLnBrk="1" latinLnBrk="0" hangingPunct="1">
       <a:defRPr sz="1200" kern="1200">
         <a:solidFill>
           <a:schemeClr val="tx1"/>
@@ -236,7 +444,7 @@
         <a:cs typeface="+mn-cs"/>
       </a:defRPr>
     </a:lvl7pPr>
-    <a:lvl8pPr marL="3200400" algn="l" defTabSz="914400" rtl="0" eaLnBrk="1" latinLnBrk="0" hangingPunct="1">
+    <a:lvl8pPr marL="3200400" algn="l" defTabSz="457200" rtl="0" eaLnBrk="1" latinLnBrk="0" hangingPunct="1">
       <a:defRPr sz="1200" kern="1200">
         <a:solidFill>
           <a:schemeClr val="tx1"/>
@@ -246,7 +454,7 @@
         <a:cs typeface="+mn-cs"/>
       </a:defRPr>
     </a:lvl8pPr>
-    <a:lvl9pPr marL="3657600" algn="l" defTabSz="914400" rtl="0" eaLnBrk="1" latinLnBrk="0" hangingPunct="1">
+    <a:lvl9pPr marL="3657600" algn="l" defTabSz="457200" rtl="0" eaLnBrk="1" latinLnBrk="0" hangingPunct="1">
       <a:defRPr sz="1200" kern="1200">
         <a:solidFill>
           <a:schemeClr val="tx1"/>
@@ -261,7 +469,7 @@
 </file>
 
 <file path=ppt/notesSlides/notesSlide1.xml><?xml version="1.0" encoding="utf-8"?>
-<p:notes xmlns:a="http://schemas.openxmlformats.org/drawingml/2006/main" xmlns:r="http://schemas.openxmlformats.org/officeDocument/2006/relationships" xmlns:p="http://schemas.openxmlformats.org/presentationml/2006/main">
+<p:notes xmlns:a="http://schemas.openxmlformats.org/drawingml/2006/main" xmlns:p="http://schemas.openxmlformats.org/presentationml/2006/main" xmlns:r="http://schemas.openxmlformats.org/officeDocument/2006/relationships">
   <p:cSld>
     <p:spTree>
       <p:nvGrpSpPr>
@@ -281,7 +489,7 @@
         <p:nvSpPr>
           <p:cNvPr id="2" name="Slide Image Placeholder 1"/>
           <p:cNvSpPr>
-            <a:spLocks noGrp="1" noRot="1" noChangeAspect="1"/>
+            <a:spLocks noGrp="1"/>
           </p:cNvSpPr>
           <p:nvPr>
             <p:ph type="sldImg" idx="2"/>
@@ -296,7 +504,7 @@
             <a:spLocks noGrp="1"/>
           </p:cNvSpPr>
           <p:nvPr>
-            <p:ph type="body" sz="quarter" idx="3"/>
+            <p:ph type="body" idx="3" sz="quarter"/>
           </p:nvPr>
         </p:nvSpPr>
         <p:spPr/>
@@ -317,7 +525,7 @@
             <a:spLocks noGrp="1"/>
           </p:cNvSpPr>
           <p:nvPr>
-            <p:ph type="sldNum" sz="quarter" idx="5"/>
+            <p:ph type="sldNum" idx="5" sz="quarter"/>
           </p:nvPr>
         </p:nvSpPr>
         <p:spPr/>
@@ -331,7 +539,7 @@
 </file>
 
 <file path=ppt/notesSlides/notesSlide10.xml><?xml version="1.0" encoding="utf-8"?>
-<p:notes xmlns:a="http://schemas.openxmlformats.org/drawingml/2006/main" xmlns:r="http://schemas.openxmlformats.org/officeDocument/2006/relationships" xmlns:p="http://schemas.openxmlformats.org/presentationml/2006/main">
+<p:notes xmlns:a="http://schemas.openxmlformats.org/drawingml/2006/main" xmlns:p="http://schemas.openxmlformats.org/presentationml/2006/main" xmlns:r="http://schemas.openxmlformats.org/officeDocument/2006/relationships">
   <p:cSld>
     <p:spTree>
       <p:nvGrpSpPr>
@@ -351,7 +559,7 @@
         <p:nvSpPr>
           <p:cNvPr id="2" name="Slide Image Placeholder 1"/>
           <p:cNvSpPr>
-            <a:spLocks noGrp="1" noRot="1" noChangeAspect="1"/>
+            <a:spLocks noGrp="1"/>
           </p:cNvSpPr>
           <p:nvPr>
             <p:ph type="sldImg" idx="2"/>
@@ -366,16 +574,16 @@
             <a:spLocks noGrp="1"/>
           </p:cNvSpPr>
           <p:nvPr>
-            <p:ph type="body" sz="quarter" idx="3"/>
-          </p:nvPr>
-        </p:nvSpPr>
-        <p:spPr/>
-        <p:txBody>
-          <a:bodyPr/>
-          <a:lstStyle/>
-          <a:p>
-            <a:r>
-              <a:t>Wrap up the presentation. Conclude that AI is amazing for transient bursts, but it cannot bend the laws of physics when a network is 100% full. Thank the audience and ask for questions.</a:t>
+            <p:ph type="body" idx="3" sz="quarter"/>
+          </p:nvPr>
+        </p:nvSpPr>
+        <p:spPr/>
+        <p:txBody>
+          <a:bodyPr/>
+          <a:lstStyle/>
+          <a:p>
+            <a:r>
+              <a:t>Look at the violin plots. ECMP is tight and narrow (predictable but mediocre). The DRL agents have wider bodies and long tails—they are aggressively hunting for better paths, which creates higher variance but much better burst mitigation.</a:t>
             </a:r>
           </a:p>
         </p:txBody>
@@ -387,7 +595,7 @@
             <a:spLocks noGrp="1"/>
           </p:cNvSpPr>
           <p:nvPr>
-            <p:ph type="sldNum" sz="quarter" idx="5"/>
+            <p:ph type="sldNum" idx="5" sz="quarter"/>
           </p:nvPr>
         </p:nvSpPr>
         <p:spPr/>
@@ -400,8 +608,8 @@
 </p:notes>
 </file>
 
-<file path=ppt/notesSlides/notesSlide2.xml><?xml version="1.0" encoding="utf-8"?>
-<p:notes xmlns:a="http://schemas.openxmlformats.org/drawingml/2006/main" xmlns:r="http://schemas.openxmlformats.org/officeDocument/2006/relationships" xmlns:p="http://schemas.openxmlformats.org/presentationml/2006/main">
+<file path=ppt/notesSlides/notesSlide11.xml><?xml version="1.0" encoding="utf-8"?>
+<p:notes xmlns:a="http://schemas.openxmlformats.org/drawingml/2006/main" xmlns:p="http://schemas.openxmlformats.org/presentationml/2006/main" xmlns:r="http://schemas.openxmlformats.org/officeDocument/2006/relationships">
   <p:cSld>
     <p:spTree>
       <p:nvGrpSpPr>
@@ -421,7 +629,7 @@
         <p:nvSpPr>
           <p:cNvPr id="2" name="Slide Image Placeholder 1"/>
           <p:cNvSpPr>
-            <a:spLocks noGrp="1" noRot="1" noChangeAspect="1"/>
+            <a:spLocks noGrp="1"/>
           </p:cNvSpPr>
           <p:nvPr>
             <p:ph type="sldImg" idx="2"/>
@@ -436,16 +644,16 @@
             <a:spLocks noGrp="1"/>
           </p:cNvSpPr>
           <p:nvPr>
-            <p:ph type="body" sz="quarter" idx="3"/>
-          </p:nvPr>
-        </p:nvSpPr>
-        <p:spPr/>
-        <p:txBody>
-          <a:bodyPr/>
-          <a:lstStyle/>
-          <a:p>
-            <a:r>
-              <a:t>Explain that traditional ECMP doesn't look at how full a link is; it just blindly hashes packets. When a massive data flow (elephant flow) hits, ECMP can accidentally send it down an already congested path, causing dropped packets.</a:t>
+            <p:ph type="body" idx="3" sz="quarter"/>
+          </p:nvPr>
+        </p:nvSpPr>
+        <p:spPr/>
+        <p:txBody>
+          <a:bodyPr/>
+          <a:lstStyle/>
+          <a:p>
+            <a:r>
+              <a:t>Wrap up the presentation. Conclude that AI is amazing for transient bursts, but it cannot bend the laws of physics when a network is 100% full. Thank the audience and ask for questions.</a:t>
             </a:r>
           </a:p>
         </p:txBody>
@@ -457,7 +665,7 @@
             <a:spLocks noGrp="1"/>
           </p:cNvSpPr>
           <p:nvPr>
-            <p:ph type="sldNum" sz="quarter" idx="5"/>
+            <p:ph type="sldNum" idx="5" sz="quarter"/>
           </p:nvPr>
         </p:nvSpPr>
         <p:spPr/>
@@ -470,8 +678,8 @@
 </p:notes>
 </file>
 
-<file path=ppt/notesSlides/notesSlide3.xml><?xml version="1.0" encoding="utf-8"?>
-<p:notes xmlns:a="http://schemas.openxmlformats.org/drawingml/2006/main" xmlns:r="http://schemas.openxmlformats.org/officeDocument/2006/relationships" xmlns:p="http://schemas.openxmlformats.org/presentationml/2006/main">
+<file path=ppt/notesSlides/notesSlide2.xml><?xml version="1.0" encoding="utf-8"?>
+<p:notes xmlns:a="http://schemas.openxmlformats.org/drawingml/2006/main" xmlns:p="http://schemas.openxmlformats.org/presentationml/2006/main" xmlns:r="http://schemas.openxmlformats.org/officeDocument/2006/relationships">
   <p:cSld>
     <p:spTree>
       <p:nvGrpSpPr>
@@ -491,7 +699,7 @@
         <p:nvSpPr>
           <p:cNvPr id="2" name="Slide Image Placeholder 1"/>
           <p:cNvSpPr>
-            <a:spLocks noGrp="1" noRot="1" noChangeAspect="1"/>
+            <a:spLocks noGrp="1"/>
           </p:cNvSpPr>
           <p:nvPr>
             <p:ph type="sldImg" idx="2"/>
@@ -506,16 +714,16 @@
             <a:spLocks noGrp="1"/>
           </p:cNvSpPr>
           <p:nvPr>
-            <p:ph type="body" sz="quarter" idx="3"/>
-          </p:nvPr>
-        </p:nvSpPr>
-        <p:spPr/>
-        <p:txBody>
-          <a:bodyPr/>
-          <a:lstStyle/>
-          <a:p>
-            <a:r>
-              <a:t>Our goal wasn't just to see if AI works, but to push it to its breaking point. We specifically wanted to see if an agent trained on one network could magically route traffic on a completely different, unseen network (zero-shot generalization).</a:t>
+            <p:ph type="body" idx="3" sz="quarter"/>
+          </p:nvPr>
+        </p:nvSpPr>
+        <p:spPr/>
+        <p:txBody>
+          <a:bodyPr/>
+          <a:lstStyle/>
+          <a:p>
+            <a:r>
+              <a:t>Explain that traditional ECMP doesn't look at how full a link is; it just blindly hashes packets. When a massive data flow (elephant flow) hits, ECMP can accidentally send it down an already congested path, causing dropped packets.</a:t>
             </a:r>
           </a:p>
         </p:txBody>
@@ -527,7 +735,7 @@
             <a:spLocks noGrp="1"/>
           </p:cNvSpPr>
           <p:nvPr>
-            <p:ph type="sldNum" sz="quarter" idx="5"/>
+            <p:ph type="sldNum" idx="5" sz="quarter"/>
           </p:nvPr>
         </p:nvSpPr>
         <p:spPr/>
@@ -540,8 +748,8 @@
 </p:notes>
 </file>
 
-<file path=ppt/notesSlides/notesSlide4.xml><?xml version="1.0" encoding="utf-8"?>
-<p:notes xmlns:a="http://schemas.openxmlformats.org/drawingml/2006/main" xmlns:r="http://schemas.openxmlformats.org/officeDocument/2006/relationships" xmlns:p="http://schemas.openxmlformats.org/presentationml/2006/main">
+<file path=ppt/notesSlides/notesSlide3.xml><?xml version="1.0" encoding="utf-8"?>
+<p:notes xmlns:a="http://schemas.openxmlformats.org/drawingml/2006/main" xmlns:p="http://schemas.openxmlformats.org/presentationml/2006/main" xmlns:r="http://schemas.openxmlformats.org/officeDocument/2006/relationships">
   <p:cSld>
     <p:spTree>
       <p:nvGrpSpPr>
@@ -561,7 +769,7 @@
         <p:nvSpPr>
           <p:cNvPr id="2" name="Slide Image Placeholder 1"/>
           <p:cNvSpPr>
-            <a:spLocks noGrp="1" noRot="1" noChangeAspect="1"/>
+            <a:spLocks noGrp="1"/>
           </p:cNvSpPr>
           <p:nvPr>
             <p:ph type="sldImg" idx="2"/>
@@ -576,16 +784,16 @@
             <a:spLocks noGrp="1"/>
           </p:cNvSpPr>
           <p:nvPr>
-            <p:ph type="body" sz="quarter" idx="3"/>
-          </p:nvPr>
-        </p:nvSpPr>
-        <p:spPr/>
-        <p:txBody>
-          <a:bodyPr/>
-          <a:lstStyle/>
-          <a:p>
-            <a:r>
-              <a:t>Point to the graph. Explain that the neural network learns to prioritize Queue Occupancy and Link Utilization over raw flow demands. The zero-padding allows the same 250-feature neural network to accept any topology size.</a:t>
+            <p:ph type="body" idx="3" sz="quarter"/>
+          </p:nvPr>
+        </p:nvSpPr>
+        <p:spPr/>
+        <p:txBody>
+          <a:bodyPr/>
+          <a:lstStyle/>
+          <a:p>
+            <a:r>
+              <a:t>Our goal wasn't just to see if AI works, but to push it to its breaking point. We specifically wanted to see if an agent trained on one network could magically route traffic on a completely different, unseen network (zero-shot generalization).</a:t>
             </a:r>
           </a:p>
         </p:txBody>
@@ -597,7 +805,7 @@
             <a:spLocks noGrp="1"/>
           </p:cNvSpPr>
           <p:nvPr>
-            <p:ph type="sldNum" sz="quarter" idx="5"/>
+            <p:ph type="sldNum" idx="5" sz="quarter"/>
           </p:nvPr>
         </p:nvSpPr>
         <p:spPr/>
@@ -610,8 +818,8 @@
 </p:notes>
 </file>
 
-<file path=ppt/notesSlides/notesSlide5.xml><?xml version="1.0" encoding="utf-8"?>
-<p:notes xmlns:a="http://schemas.openxmlformats.org/drawingml/2006/main" xmlns:r="http://schemas.openxmlformats.org/officeDocument/2006/relationships" xmlns:p="http://schemas.openxmlformats.org/presentationml/2006/main">
+<file path=ppt/notesSlides/notesSlide4.xml><?xml version="1.0" encoding="utf-8"?>
+<p:notes xmlns:a="http://schemas.openxmlformats.org/drawingml/2006/main" xmlns:p="http://schemas.openxmlformats.org/presentationml/2006/main" xmlns:r="http://schemas.openxmlformats.org/officeDocument/2006/relationships">
   <p:cSld>
     <p:spTree>
       <p:nvGrpSpPr>
@@ -631,7 +839,7 @@
         <p:nvSpPr>
           <p:cNvPr id="2" name="Slide Image Placeholder 1"/>
           <p:cNvSpPr>
-            <a:spLocks noGrp="1" noRot="1" noChangeAspect="1"/>
+            <a:spLocks noGrp="1"/>
           </p:cNvSpPr>
           <p:nvPr>
             <p:ph type="sldImg" idx="2"/>
@@ -646,16 +854,16 @@
             <a:spLocks noGrp="1"/>
           </p:cNvSpPr>
           <p:nvPr>
-            <p:ph type="body" sz="quarter" idx="3"/>
-          </p:nvPr>
-        </p:nvSpPr>
-        <p:spPr/>
-        <p:txBody>
-          <a:bodyPr/>
-          <a:lstStyle/>
-          <a:p>
-            <a:r>
-              <a:t>Show how DQN's actions (in red) are locked into 10 rigid bars, whereas PPO (in blue) can output any fine-tuned routing weight, allowing for much smoother traffic engineering.</a:t>
+            <p:ph type="body" idx="3" sz="quarter"/>
+          </p:nvPr>
+        </p:nvSpPr>
+        <p:spPr/>
+        <p:txBody>
+          <a:bodyPr/>
+          <a:lstStyle/>
+          <a:p>
+            <a:r>
+              <a:t>Point to the graph. Explain that the neural network learns to prioritize Queue Occupancy and Link Utilization over raw flow demands. The zero-padding allows the same 250-feature neural network to accept any topology size.</a:t>
             </a:r>
           </a:p>
         </p:txBody>
@@ -667,7 +875,7 @@
             <a:spLocks noGrp="1"/>
           </p:cNvSpPr>
           <p:nvPr>
-            <p:ph type="sldNum" sz="quarter" idx="5"/>
+            <p:ph type="sldNum" idx="5" sz="quarter"/>
           </p:nvPr>
         </p:nvSpPr>
         <p:spPr/>
@@ -680,8 +888,8 @@
 </p:notes>
 </file>
 
-<file path=ppt/notesSlides/notesSlide6.xml><?xml version="1.0" encoding="utf-8"?>
-<p:notes xmlns:a="http://schemas.openxmlformats.org/drawingml/2006/main" xmlns:r="http://schemas.openxmlformats.org/officeDocument/2006/relationships" xmlns:p="http://schemas.openxmlformats.org/presentationml/2006/main">
+<file path=ppt/notesSlides/notesSlide5.xml><?xml version="1.0" encoding="utf-8"?>
+<p:notes xmlns:a="http://schemas.openxmlformats.org/drawingml/2006/main" xmlns:p="http://schemas.openxmlformats.org/presentationml/2006/main" xmlns:r="http://schemas.openxmlformats.org/officeDocument/2006/relationships">
   <p:cSld>
     <p:spTree>
       <p:nvGrpSpPr>
@@ -701,7 +909,7 @@
         <p:nvSpPr>
           <p:cNvPr id="2" name="Slide Image Placeholder 1"/>
           <p:cNvSpPr>
-            <a:spLocks noGrp="1" noRot="1" noChangeAspect="1"/>
+            <a:spLocks noGrp="1"/>
           </p:cNvSpPr>
           <p:nvPr>
             <p:ph type="sldImg" idx="2"/>
@@ -716,16 +924,16 @@
             <a:spLocks noGrp="1"/>
           </p:cNvSpPr>
           <p:nvPr>
-            <p:ph type="body" sz="quarter" idx="3"/>
-          </p:nvPr>
-        </p:nvSpPr>
-        <p:spPr/>
-        <p:txBody>
-          <a:bodyPr/>
-          <a:lstStyle/>
-          <a:p>
-            <a:r>
-              <a:t>Direct the audience to the horizontal bar chart. Explain that PPO and DQN both significantly outperform ECMP here. Because they observe real-time telemetry, they immediately route burst traffic away from the bottleneck, preventing packet drops.</a:t>
+            <p:ph type="body" idx="3" sz="quarter"/>
+          </p:nvPr>
+        </p:nvSpPr>
+        <p:spPr/>
+        <p:txBody>
+          <a:bodyPr/>
+          <a:lstStyle/>
+          <a:p>
+            <a:r>
+              <a:t>Show how DQN's actions (in red) are locked into 10 rigid bars, whereas PPO (in blue) can output any fine-tuned routing weight, allowing for much smoother traffic engineering.</a:t>
             </a:r>
           </a:p>
         </p:txBody>
@@ -737,7 +945,7 @@
             <a:spLocks noGrp="1"/>
           </p:cNvSpPr>
           <p:nvPr>
-            <p:ph type="sldNum" sz="quarter" idx="5"/>
+            <p:ph type="sldNum" idx="5" sz="quarter"/>
           </p:nvPr>
         </p:nvSpPr>
         <p:spPr/>
@@ -750,8 +958,8 @@
 </p:notes>
 </file>
 
-<file path=ppt/notesSlides/notesSlide7.xml><?xml version="1.0" encoding="utf-8"?>
-<p:notes xmlns:a="http://schemas.openxmlformats.org/drawingml/2006/main" xmlns:r="http://schemas.openxmlformats.org/officeDocument/2006/relationships" xmlns:p="http://schemas.openxmlformats.org/presentationml/2006/main">
+<file path=ppt/notesSlides/notesSlide6.xml><?xml version="1.0" encoding="utf-8"?>
+<p:notes xmlns:a="http://schemas.openxmlformats.org/drawingml/2006/main" xmlns:p="http://schemas.openxmlformats.org/presentationml/2006/main" xmlns:r="http://schemas.openxmlformats.org/officeDocument/2006/relationships">
   <p:cSld>
     <p:spTree>
       <p:nvGrpSpPr>
@@ -771,7 +979,7 @@
         <p:nvSpPr>
           <p:cNvPr id="2" name="Slide Image Placeholder 1"/>
           <p:cNvSpPr>
-            <a:spLocks noGrp="1" noRot="1" noChangeAspect="1"/>
+            <a:spLocks noGrp="1"/>
           </p:cNvSpPr>
           <p:nvPr>
             <p:ph type="sldImg" idx="2"/>
@@ -786,16 +994,16 @@
             <a:spLocks noGrp="1"/>
           </p:cNvSpPr>
           <p:nvPr>
-            <p:ph type="body" sz="quarter" idx="3"/>
-          </p:nvPr>
-        </p:nvSpPr>
-        <p:spPr/>
-        <p:txBody>
-          <a:bodyPr/>
-          <a:lstStyle/>
-          <a:p>
-            <a:r>
-              <a:t>This is our most critical academic finding. Look at the square markers on the scatter plot. Under extreme congestion, DRL fails to beat ECMP. Why? Because the network is physically full. Constantly shifting traffic just causes packet reordering overhead. This proves we need admission control.</a:t>
+            <p:ph type="body" idx="3" sz="quarter"/>
+          </p:nvPr>
+        </p:nvSpPr>
+        <p:spPr/>
+        <p:txBody>
+          <a:bodyPr/>
+          <a:lstStyle/>
+          <a:p>
+            <a:r>
+              <a:t>In this slide, we focus on our primary success: moderate traffic. This is the optimal operating window for our models where they both clearly beat ECMP. As you can see from the plot, the agents learn to route around early congestion.</a:t>
             </a:r>
           </a:p>
         </p:txBody>
@@ -807,7 +1015,7 @@
             <a:spLocks noGrp="1"/>
           </p:cNvSpPr>
           <p:nvPr>
-            <p:ph type="sldNum" sz="quarter" idx="5"/>
+            <p:ph type="sldNum" idx="5" sz="quarter"/>
           </p:nvPr>
         </p:nvSpPr>
         <p:spPr/>
@@ -820,8 +1028,8 @@
 </p:notes>
 </file>
 
-<file path=ppt/notesSlides/notesSlide8.xml><?xml version="1.0" encoding="utf-8"?>
-<p:notes xmlns:a="http://schemas.openxmlformats.org/drawingml/2006/main" xmlns:r="http://schemas.openxmlformats.org/officeDocument/2006/relationships" xmlns:p="http://schemas.openxmlformats.org/presentationml/2006/main">
+<file path=ppt/notesSlides/notesSlide7.xml><?xml version="1.0" encoding="utf-8"?>
+<p:notes xmlns:a="http://schemas.openxmlformats.org/drawingml/2006/main" xmlns:p="http://schemas.openxmlformats.org/presentationml/2006/main" xmlns:r="http://schemas.openxmlformats.org/officeDocument/2006/relationships">
   <p:cSld>
     <p:spTree>
       <p:nvGrpSpPr>
@@ -841,7 +1049,7 @@
         <p:nvSpPr>
           <p:cNvPr id="2" name="Slide Image Placeholder 1"/>
           <p:cNvSpPr>
-            <a:spLocks noGrp="1" noRot="1" noChangeAspect="1"/>
+            <a:spLocks noGrp="1"/>
           </p:cNvSpPr>
           <p:nvPr>
             <p:ph type="sldImg" idx="2"/>
@@ -856,16 +1064,16 @@
             <a:spLocks noGrp="1"/>
           </p:cNvSpPr>
           <p:nvPr>
-            <p:ph type="body" sz="quarter" idx="3"/>
-          </p:nvPr>
-        </p:nvSpPr>
-        <p:spPr/>
-        <p:txBody>
-          <a:bodyPr/>
-          <a:lstStyle/>
-          <a:p>
-            <a:r>
-              <a:t>We threw the agents into completely unseen networks ranging up to 100 nodes. As expected, bigger networks are harder to route, so reward drops. But notice how PPO (the blue line) consistently stays above DQN (the red line), proving robust zero-shot transfer.</a:t>
+            <p:ph type="body" idx="3" sz="quarter"/>
+          </p:nvPr>
+        </p:nvSpPr>
+        <p:spPr/>
+        <p:txBody>
+          <a:bodyPr/>
+          <a:lstStyle/>
+          <a:p>
+            <a:r>
+              <a:t>Under extreme burst traffic, DQN handled the volatility well, but PPO did not. Even though PPO survives for more timesteps before failing, its overall efficiency per step drops below the ECMP baseline.</a:t>
             </a:r>
           </a:p>
         </p:txBody>
@@ -877,7 +1085,7 @@
             <a:spLocks noGrp="1"/>
           </p:cNvSpPr>
           <p:nvPr>
-            <p:ph type="sldNum" sz="quarter" idx="5"/>
+            <p:ph type="sldNum" idx="5" sz="quarter"/>
           </p:nvPr>
         </p:nvSpPr>
         <p:spPr/>
@@ -890,8 +1098,8 @@
 </p:notes>
 </file>
 
-<file path=ppt/notesSlides/notesSlide9.xml><?xml version="1.0" encoding="utf-8"?>
-<p:notes xmlns:a="http://schemas.openxmlformats.org/drawingml/2006/main" xmlns:r="http://schemas.openxmlformats.org/officeDocument/2006/relationships" xmlns:p="http://schemas.openxmlformats.org/presentationml/2006/main">
+<file path=ppt/notesSlides/notesSlide8.xml><?xml version="1.0" encoding="utf-8"?>
+<p:notes xmlns:a="http://schemas.openxmlformats.org/drawingml/2006/main" xmlns:p="http://schemas.openxmlformats.org/presentationml/2006/main" xmlns:r="http://schemas.openxmlformats.org/officeDocument/2006/relationships">
   <p:cSld>
     <p:spTree>
       <p:nvGrpSpPr>
@@ -911,7 +1119,7 @@
         <p:nvSpPr>
           <p:cNvPr id="2" name="Slide Image Placeholder 1"/>
           <p:cNvSpPr>
-            <a:spLocks noGrp="1" noRot="1" noChangeAspect="1"/>
+            <a:spLocks noGrp="1"/>
           </p:cNvSpPr>
           <p:nvPr>
             <p:ph type="sldImg" idx="2"/>
@@ -926,16 +1134,16 @@
             <a:spLocks noGrp="1"/>
           </p:cNvSpPr>
           <p:nvPr>
-            <p:ph type="body" sz="quarter" idx="3"/>
-          </p:nvPr>
-        </p:nvSpPr>
-        <p:spPr/>
-        <p:txBody>
-          <a:bodyPr/>
-          <a:lstStyle/>
-          <a:p>
-            <a:r>
-              <a:t>Look at the violin plots. ECMP is tight and narrow (predictable but mediocre). The DRL agents have wider bodies and long tails—they are aggressively hunting for better paths, which creates higher variance but much better burst mitigation.</a:t>
+            <p:ph type="body" idx="3" sz="quarter"/>
+          </p:nvPr>
+        </p:nvSpPr>
+        <p:spPr/>
+        <p:txBody>
+          <a:bodyPr/>
+          <a:lstStyle/>
+          <a:p>
+            <a:r>
+              <a:t>This is our most critical academic finding. Look at the square markers on the scatter plot. Under extreme congestion, DRL fails to beat ECMP. Why? Because the network is physically full. Constantly shifting traffic just causes packet reordering overhead. This proves we need admission control.</a:t>
             </a:r>
           </a:p>
         </p:txBody>
@@ -947,7 +1155,77 @@
             <a:spLocks noGrp="1"/>
           </p:cNvSpPr>
           <p:nvPr>
-            <p:ph type="sldNum" sz="quarter" idx="5"/>
+            <p:ph type="sldNum" idx="5" sz="quarter"/>
+          </p:nvPr>
+        </p:nvSpPr>
+        <p:spPr/>
+      </p:sp>
+    </p:spTree>
+  </p:cSld>
+  <p:clrMapOvr>
+    <a:masterClrMapping/>
+  </p:clrMapOvr>
+</p:notes>
+</file>
+
+<file path=ppt/notesSlides/notesSlide9.xml><?xml version="1.0" encoding="utf-8"?>
+<p:notes xmlns:a="http://schemas.openxmlformats.org/drawingml/2006/main" xmlns:p="http://schemas.openxmlformats.org/presentationml/2006/main" xmlns:r="http://schemas.openxmlformats.org/officeDocument/2006/relationships">
+  <p:cSld>
+    <p:spTree>
+      <p:nvGrpSpPr>
+        <p:cNvPr id="1" name=""/>
+        <p:cNvGrpSpPr/>
+        <p:nvPr/>
+      </p:nvGrpSpPr>
+      <p:grpSpPr>
+        <a:xfrm>
+          <a:off x="0" y="0"/>
+          <a:ext cx="0" cy="0"/>
+          <a:chOff x="0" y="0"/>
+          <a:chExt cx="0" cy="0"/>
+        </a:xfrm>
+      </p:grpSpPr>
+      <p:sp>
+        <p:nvSpPr>
+          <p:cNvPr id="2" name="Slide Image Placeholder 1"/>
+          <p:cNvSpPr>
+            <a:spLocks noGrp="1"/>
+          </p:cNvSpPr>
+          <p:nvPr>
+            <p:ph type="sldImg" idx="2"/>
+          </p:nvPr>
+        </p:nvSpPr>
+        <p:spPr/>
+      </p:sp>
+      <p:sp>
+        <p:nvSpPr>
+          <p:cNvPr id="3" name="Notes Placeholder 2"/>
+          <p:cNvSpPr>
+            <a:spLocks noGrp="1"/>
+          </p:cNvSpPr>
+          <p:nvPr>
+            <p:ph type="body" idx="3" sz="quarter"/>
+          </p:nvPr>
+        </p:nvSpPr>
+        <p:spPr/>
+        <p:txBody>
+          <a:bodyPr/>
+          <a:lstStyle/>
+          <a:p>
+            <a:r>
+              <a:t>We threw the agents into completely unseen networks ranging up to 100 nodes. As expected, bigger networks are harder to route, so reward drops. But notice how PPO (the blue line) consistently stays above DQN (the red line), proving robust zero-shot transfer.</a:t>
+            </a:r>
+          </a:p>
+        </p:txBody>
+      </p:sp>
+      <p:sp>
+        <p:nvSpPr>
+          <p:cNvPr id="4" name="Slide Number Placeholder 3"/>
+          <p:cNvSpPr>
+            <a:spLocks noGrp="1"/>
+          </p:cNvSpPr>
+          <p:nvPr>
+            <p:ph type="sldNum" idx="5" sz="quarter"/>
           </p:nvPr>
         </p:nvSpPr>
         <p:spPr/>
@@ -998,9 +1276,10 @@
           <a:lstStyle/>
           <a:p>
             <a:r>
-              <a:rPr lang="en-US"/>
+              <a:rPr lang="en-US" smtClean="0"/>
               <a:t>Click to edit Master title style</a:t>
             </a:r>
+            <a:endParaRPr lang="en-US"/>
           </a:p>
         </p:txBody>
       </p:sp>
@@ -1116,9 +1395,10 @@
           </a:lstStyle>
           <a:p>
             <a:r>
-              <a:rPr lang="en-US"/>
+              <a:rPr lang="en-US" smtClean="0"/>
               <a:t>Click to edit Master subtitle style</a:t>
             </a:r>
+            <a:endParaRPr lang="en-US"/>
           </a:p>
         </p:txBody>
       </p:sp>
@@ -1139,7 +1419,7 @@
           <a:p>
             <a:fld id="{5BCAD085-E8A6-8845-BD4E-CB4CCA059FC4}" type="datetimeFigureOut">
               <a:rPr lang="en-US" smtClean="0"/>
-              <a:t>22-Aug-26</a:t>
+              <a:t>1/27/13</a:t>
             </a:fld>
             <a:endParaRPr lang="en-US"/>
           </a:p>
@@ -1233,9 +1513,10 @@
           <a:lstStyle/>
           <a:p>
             <a:r>
-              <a:rPr lang="en-US"/>
+              <a:rPr lang="en-US" smtClean="0"/>
               <a:t>Click to edit Master title style</a:t>
             </a:r>
+            <a:endParaRPr lang="en-US"/>
           </a:p>
         </p:txBody>
       </p:sp>
@@ -1256,37 +1537,38 @@
           <a:p>
             <a:pPr lvl="0"/>
             <a:r>
-              <a:rPr lang="en-US"/>
+              <a:rPr lang="en-US" smtClean="0"/>
               <a:t>Click to edit Master text styles</a:t>
             </a:r>
           </a:p>
           <a:p>
             <a:pPr lvl="1"/>
             <a:r>
-              <a:rPr lang="en-US"/>
+              <a:rPr lang="en-US" smtClean="0"/>
               <a:t>Second level</a:t>
             </a:r>
           </a:p>
           <a:p>
             <a:pPr lvl="2"/>
             <a:r>
-              <a:rPr lang="en-US"/>
+              <a:rPr lang="en-US" smtClean="0"/>
               <a:t>Third level</a:t>
             </a:r>
           </a:p>
           <a:p>
             <a:pPr lvl="3"/>
             <a:r>
-              <a:rPr lang="en-US"/>
+              <a:rPr lang="en-US" smtClean="0"/>
               <a:t>Fourth level</a:t>
             </a:r>
           </a:p>
           <a:p>
             <a:pPr lvl="4"/>
             <a:r>
-              <a:rPr lang="en-US"/>
+              <a:rPr lang="en-US" smtClean="0"/>
               <a:t>Fifth level</a:t>
             </a:r>
+            <a:endParaRPr lang="en-US"/>
           </a:p>
         </p:txBody>
       </p:sp>
@@ -1307,7 +1589,7 @@
           <a:p>
             <a:fld id="{5BCAD085-E8A6-8845-BD4E-CB4CCA059FC4}" type="datetimeFigureOut">
               <a:rPr lang="en-US" smtClean="0"/>
-              <a:t>22-Aug-26</a:t>
+              <a:t>1/27/13</a:t>
             </a:fld>
             <a:endParaRPr lang="en-US"/>
           </a:p>
@@ -1406,9 +1688,10 @@
           <a:lstStyle/>
           <a:p>
             <a:r>
-              <a:rPr lang="en-US"/>
+              <a:rPr lang="en-US" smtClean="0"/>
               <a:t>Click to edit Master title style</a:t>
             </a:r>
+            <a:endParaRPr lang="en-US"/>
           </a:p>
         </p:txBody>
       </p:sp>
@@ -1434,37 +1717,38 @@
           <a:p>
             <a:pPr lvl="0"/>
             <a:r>
-              <a:rPr lang="en-US"/>
+              <a:rPr lang="en-US" smtClean="0"/>
               <a:t>Click to edit Master text styles</a:t>
             </a:r>
           </a:p>
           <a:p>
             <a:pPr lvl="1"/>
             <a:r>
-              <a:rPr lang="en-US"/>
+              <a:rPr lang="en-US" smtClean="0"/>
               <a:t>Second level</a:t>
             </a:r>
           </a:p>
           <a:p>
             <a:pPr lvl="2"/>
             <a:r>
-              <a:rPr lang="en-US"/>
+              <a:rPr lang="en-US" smtClean="0"/>
               <a:t>Third level</a:t>
             </a:r>
           </a:p>
           <a:p>
             <a:pPr lvl="3"/>
             <a:r>
-              <a:rPr lang="en-US"/>
+              <a:rPr lang="en-US" smtClean="0"/>
               <a:t>Fourth level</a:t>
             </a:r>
           </a:p>
           <a:p>
             <a:pPr lvl="4"/>
             <a:r>
-              <a:rPr lang="en-US"/>
+              <a:rPr lang="en-US" smtClean="0"/>
               <a:t>Fifth level</a:t>
             </a:r>
+            <a:endParaRPr lang="en-US"/>
           </a:p>
         </p:txBody>
       </p:sp>
@@ -1485,7 +1769,7 @@
           <a:p>
             <a:fld id="{5BCAD085-E8A6-8845-BD4E-CB4CCA059FC4}" type="datetimeFigureOut">
               <a:rPr lang="en-US" smtClean="0"/>
-              <a:t>22-Aug-26</a:t>
+              <a:t>1/27/13</a:t>
             </a:fld>
             <a:endParaRPr lang="en-US"/>
           </a:p>
@@ -1579,9 +1863,10 @@
           <a:lstStyle/>
           <a:p>
             <a:r>
-              <a:rPr lang="en-US"/>
+              <a:rPr lang="en-US" smtClean="0"/>
               <a:t>Click to edit Master title style</a:t>
             </a:r>
+            <a:endParaRPr lang="en-US"/>
           </a:p>
         </p:txBody>
       </p:sp>
@@ -1602,37 +1887,38 @@
           <a:p>
             <a:pPr lvl="0"/>
             <a:r>
-              <a:rPr lang="en-US"/>
+              <a:rPr lang="en-US" smtClean="0"/>
               <a:t>Click to edit Master text styles</a:t>
             </a:r>
           </a:p>
           <a:p>
             <a:pPr lvl="1"/>
             <a:r>
-              <a:rPr lang="en-US"/>
+              <a:rPr lang="en-US" smtClean="0"/>
               <a:t>Second level</a:t>
             </a:r>
           </a:p>
           <a:p>
             <a:pPr lvl="2"/>
             <a:r>
-              <a:rPr lang="en-US"/>
+              <a:rPr lang="en-US" smtClean="0"/>
               <a:t>Third level</a:t>
             </a:r>
           </a:p>
           <a:p>
             <a:pPr lvl="3"/>
             <a:r>
-              <a:rPr lang="en-US"/>
+              <a:rPr lang="en-US" smtClean="0"/>
               <a:t>Fourth level</a:t>
             </a:r>
           </a:p>
           <a:p>
             <a:pPr lvl="4"/>
             <a:r>
-              <a:rPr lang="en-US"/>
+              <a:rPr lang="en-US" smtClean="0"/>
               <a:t>Fifth level</a:t>
             </a:r>
+            <a:endParaRPr lang="en-US"/>
           </a:p>
         </p:txBody>
       </p:sp>
@@ -1653,7 +1939,7 @@
           <a:p>
             <a:fld id="{5BCAD085-E8A6-8845-BD4E-CB4CCA059FC4}" type="datetimeFigureOut">
               <a:rPr lang="en-US" smtClean="0"/>
-              <a:t>22-Aug-26</a:t>
+              <a:t>1/27/13</a:t>
             </a:fld>
             <a:endParaRPr lang="en-US"/>
           </a:p>
@@ -1756,9 +2042,10 @@
           </a:lstStyle>
           <a:p>
             <a:r>
-              <a:rPr lang="en-US"/>
+              <a:rPr lang="en-US" smtClean="0"/>
               <a:t>Click to edit Master title style</a:t>
             </a:r>
+            <a:endParaRPr lang="en-US"/>
           </a:p>
         </p:txBody>
       </p:sp>
@@ -1875,7 +2162,7 @@
           <a:p>
             <a:pPr lvl="0"/>
             <a:r>
-              <a:rPr lang="en-US"/>
+              <a:rPr lang="en-US" smtClean="0"/>
               <a:t>Click to edit Master text styles</a:t>
             </a:r>
           </a:p>
@@ -1898,7 +2185,7 @@
           <a:p>
             <a:fld id="{5BCAD085-E8A6-8845-BD4E-CB4CCA059FC4}" type="datetimeFigureOut">
               <a:rPr lang="en-US" smtClean="0"/>
-              <a:t>22-Aug-26</a:t>
+              <a:t>1/27/13</a:t>
             </a:fld>
             <a:endParaRPr lang="en-US"/>
           </a:p>
@@ -1992,9 +2279,10 @@
           <a:lstStyle/>
           <a:p>
             <a:r>
-              <a:rPr lang="en-US"/>
+              <a:rPr lang="en-US" smtClean="0"/>
               <a:t>Click to edit Master title style</a:t>
             </a:r>
+            <a:endParaRPr lang="en-US"/>
           </a:p>
         </p:txBody>
       </p:sp>
@@ -2048,37 +2336,38 @@
           <a:p>
             <a:pPr lvl="0"/>
             <a:r>
-              <a:rPr lang="en-US"/>
+              <a:rPr lang="en-US" smtClean="0"/>
               <a:t>Click to edit Master text styles</a:t>
             </a:r>
           </a:p>
           <a:p>
             <a:pPr lvl="1"/>
             <a:r>
-              <a:rPr lang="en-US"/>
+              <a:rPr lang="en-US" smtClean="0"/>
               <a:t>Second level</a:t>
             </a:r>
           </a:p>
           <a:p>
             <a:pPr lvl="2"/>
             <a:r>
-              <a:rPr lang="en-US"/>
+              <a:rPr lang="en-US" smtClean="0"/>
               <a:t>Third level</a:t>
             </a:r>
           </a:p>
           <a:p>
             <a:pPr lvl="3"/>
             <a:r>
-              <a:rPr lang="en-US"/>
+              <a:rPr lang="en-US" smtClean="0"/>
               <a:t>Fourth level</a:t>
             </a:r>
           </a:p>
           <a:p>
             <a:pPr lvl="4"/>
             <a:r>
-              <a:rPr lang="en-US"/>
+              <a:rPr lang="en-US" smtClean="0"/>
               <a:t>Fifth level</a:t>
             </a:r>
+            <a:endParaRPr lang="en-US"/>
           </a:p>
         </p:txBody>
       </p:sp>
@@ -2132,37 +2421,38 @@
           <a:p>
             <a:pPr lvl="0"/>
             <a:r>
-              <a:rPr lang="en-US"/>
+              <a:rPr lang="en-US" smtClean="0"/>
               <a:t>Click to edit Master text styles</a:t>
             </a:r>
           </a:p>
           <a:p>
             <a:pPr lvl="1"/>
             <a:r>
-              <a:rPr lang="en-US"/>
+              <a:rPr lang="en-US" smtClean="0"/>
               <a:t>Second level</a:t>
             </a:r>
           </a:p>
           <a:p>
             <a:pPr lvl="2"/>
             <a:r>
-              <a:rPr lang="en-US"/>
+              <a:rPr lang="en-US" smtClean="0"/>
               <a:t>Third level</a:t>
             </a:r>
           </a:p>
           <a:p>
             <a:pPr lvl="3"/>
             <a:r>
-              <a:rPr lang="en-US"/>
+              <a:rPr lang="en-US" smtClean="0"/>
               <a:t>Fourth level</a:t>
             </a:r>
           </a:p>
           <a:p>
             <a:pPr lvl="4"/>
             <a:r>
-              <a:rPr lang="en-US"/>
+              <a:rPr lang="en-US" smtClean="0"/>
               <a:t>Fifth level</a:t>
             </a:r>
+            <a:endParaRPr lang="en-US"/>
           </a:p>
         </p:txBody>
       </p:sp>
@@ -2183,7 +2473,7 @@
           <a:p>
             <a:fld id="{5BCAD085-E8A6-8845-BD4E-CB4CCA059FC4}" type="datetimeFigureOut">
               <a:rPr lang="en-US" smtClean="0"/>
-              <a:t>22-Aug-26</a:t>
+              <a:t>1/27/13</a:t>
             </a:fld>
             <a:endParaRPr lang="en-US"/>
           </a:p>
@@ -2281,9 +2571,10 @@
           </a:lstStyle>
           <a:p>
             <a:r>
-              <a:rPr lang="en-US"/>
+              <a:rPr lang="en-US" smtClean="0"/>
               <a:t>Click to edit Master title style</a:t>
             </a:r>
+            <a:endParaRPr lang="en-US"/>
           </a:p>
         </p:txBody>
       </p:sp>
@@ -2346,7 +2637,7 @@
           <a:p>
             <a:pPr lvl="0"/>
             <a:r>
-              <a:rPr lang="en-US"/>
+              <a:rPr lang="en-US" smtClean="0"/>
               <a:t>Click to edit Master text styles</a:t>
             </a:r>
           </a:p>
@@ -2402,37 +2693,38 @@
           <a:p>
             <a:pPr lvl="0"/>
             <a:r>
-              <a:rPr lang="en-US"/>
+              <a:rPr lang="en-US" smtClean="0"/>
               <a:t>Click to edit Master text styles</a:t>
             </a:r>
           </a:p>
           <a:p>
             <a:pPr lvl="1"/>
             <a:r>
-              <a:rPr lang="en-US"/>
+              <a:rPr lang="en-US" smtClean="0"/>
               <a:t>Second level</a:t>
             </a:r>
           </a:p>
           <a:p>
             <a:pPr lvl="2"/>
             <a:r>
-              <a:rPr lang="en-US"/>
+              <a:rPr lang="en-US" smtClean="0"/>
               <a:t>Third level</a:t>
             </a:r>
           </a:p>
           <a:p>
             <a:pPr lvl="3"/>
             <a:r>
-              <a:rPr lang="en-US"/>
+              <a:rPr lang="en-US" smtClean="0"/>
               <a:t>Fourth level</a:t>
             </a:r>
           </a:p>
           <a:p>
             <a:pPr lvl="4"/>
             <a:r>
-              <a:rPr lang="en-US"/>
+              <a:rPr lang="en-US" smtClean="0"/>
               <a:t>Fifth level</a:t>
             </a:r>
+            <a:endParaRPr lang="en-US"/>
           </a:p>
         </p:txBody>
       </p:sp>
@@ -2495,7 +2787,7 @@
           <a:p>
             <a:pPr lvl="0"/>
             <a:r>
-              <a:rPr lang="en-US"/>
+              <a:rPr lang="en-US" smtClean="0"/>
               <a:t>Click to edit Master text styles</a:t>
             </a:r>
           </a:p>
@@ -2551,37 +2843,38 @@
           <a:p>
             <a:pPr lvl="0"/>
             <a:r>
-              <a:rPr lang="en-US"/>
+              <a:rPr lang="en-US" smtClean="0"/>
               <a:t>Click to edit Master text styles</a:t>
             </a:r>
           </a:p>
           <a:p>
             <a:pPr lvl="1"/>
             <a:r>
-              <a:rPr lang="en-US"/>
+              <a:rPr lang="en-US" smtClean="0"/>
               <a:t>Second level</a:t>
             </a:r>
           </a:p>
           <a:p>
             <a:pPr lvl="2"/>
             <a:r>
-              <a:rPr lang="en-US"/>
+              <a:rPr lang="en-US" smtClean="0"/>
               <a:t>Third level</a:t>
             </a:r>
           </a:p>
           <a:p>
             <a:pPr lvl="3"/>
             <a:r>
-              <a:rPr lang="en-US"/>
+              <a:rPr lang="en-US" smtClean="0"/>
               <a:t>Fourth level</a:t>
             </a:r>
           </a:p>
           <a:p>
             <a:pPr lvl="4"/>
             <a:r>
-              <a:rPr lang="en-US"/>
+              <a:rPr lang="en-US" smtClean="0"/>
               <a:t>Fifth level</a:t>
             </a:r>
+            <a:endParaRPr lang="en-US"/>
           </a:p>
         </p:txBody>
       </p:sp>
@@ -2602,7 +2895,7 @@
           <a:p>
             <a:fld id="{5BCAD085-E8A6-8845-BD4E-CB4CCA059FC4}" type="datetimeFigureOut">
               <a:rPr lang="en-US" smtClean="0"/>
-              <a:t>22-Aug-26</a:t>
+              <a:t>1/27/13</a:t>
             </a:fld>
             <a:endParaRPr lang="en-US"/>
           </a:p>
@@ -2696,9 +2989,10 @@
           <a:lstStyle/>
           <a:p>
             <a:r>
-              <a:rPr lang="en-US"/>
+              <a:rPr lang="en-US" smtClean="0"/>
               <a:t>Click to edit Master title style</a:t>
             </a:r>
+            <a:endParaRPr lang="en-US"/>
           </a:p>
         </p:txBody>
       </p:sp>
@@ -2719,7 +3013,7 @@
           <a:p>
             <a:fld id="{5BCAD085-E8A6-8845-BD4E-CB4CCA059FC4}" type="datetimeFigureOut">
               <a:rPr lang="en-US" smtClean="0"/>
-              <a:t>22-Aug-26</a:t>
+              <a:t>1/27/13</a:t>
             </a:fld>
             <a:endParaRPr lang="en-US"/>
           </a:p>
@@ -2814,7 +3108,7 @@
           <a:p>
             <a:fld id="{5BCAD085-E8A6-8845-BD4E-CB4CCA059FC4}" type="datetimeFigureOut">
               <a:rPr lang="en-US" smtClean="0"/>
-              <a:t>22-Aug-26</a:t>
+              <a:t>1/27/13</a:t>
             </a:fld>
             <a:endParaRPr lang="en-US"/>
           </a:p>
@@ -2917,9 +3211,10 @@
           </a:lstStyle>
           <a:p>
             <a:r>
-              <a:rPr lang="en-US"/>
+              <a:rPr lang="en-US" smtClean="0"/>
               <a:t>Click to edit Master title style</a:t>
             </a:r>
+            <a:endParaRPr lang="en-US"/>
           </a:p>
         </p:txBody>
       </p:sp>
@@ -2973,37 +3268,38 @@
           <a:p>
             <a:pPr lvl="0"/>
             <a:r>
-              <a:rPr lang="en-US"/>
+              <a:rPr lang="en-US" smtClean="0"/>
               <a:t>Click to edit Master text styles</a:t>
             </a:r>
           </a:p>
           <a:p>
             <a:pPr lvl="1"/>
             <a:r>
-              <a:rPr lang="en-US"/>
+              <a:rPr lang="en-US" smtClean="0"/>
               <a:t>Second level</a:t>
             </a:r>
           </a:p>
           <a:p>
             <a:pPr lvl="2"/>
             <a:r>
-              <a:rPr lang="en-US"/>
+              <a:rPr lang="en-US" smtClean="0"/>
               <a:t>Third level</a:t>
             </a:r>
           </a:p>
           <a:p>
             <a:pPr lvl="3"/>
             <a:r>
-              <a:rPr lang="en-US"/>
+              <a:rPr lang="en-US" smtClean="0"/>
               <a:t>Fourth level</a:t>
             </a:r>
           </a:p>
           <a:p>
             <a:pPr lvl="4"/>
             <a:r>
-              <a:rPr lang="en-US"/>
+              <a:rPr lang="en-US" smtClean="0"/>
               <a:t>Fifth level</a:t>
             </a:r>
+            <a:endParaRPr lang="en-US"/>
           </a:p>
         </p:txBody>
       </p:sp>
@@ -3066,7 +3362,7 @@
           <a:p>
             <a:pPr lvl="0"/>
             <a:r>
-              <a:rPr lang="en-US"/>
+              <a:rPr lang="en-US" smtClean="0"/>
               <a:t>Click to edit Master text styles</a:t>
             </a:r>
           </a:p>
@@ -3089,7 +3385,7 @@
           <a:p>
             <a:fld id="{5BCAD085-E8A6-8845-BD4E-CB4CCA059FC4}" type="datetimeFigureOut">
               <a:rPr lang="en-US" smtClean="0"/>
-              <a:t>22-Aug-26</a:t>
+              <a:t>1/27/13</a:t>
             </a:fld>
             <a:endParaRPr lang="en-US"/>
           </a:p>
@@ -3192,9 +3488,10 @@
           </a:lstStyle>
           <a:p>
             <a:r>
-              <a:rPr lang="en-US"/>
+              <a:rPr lang="en-US" smtClean="0"/>
               <a:t>Click to edit Master title style</a:t>
             </a:r>
+            <a:endParaRPr lang="en-US"/>
           </a:p>
         </p:txBody>
       </p:sp>
@@ -3318,7 +3615,7 @@
           <a:p>
             <a:pPr lvl="0"/>
             <a:r>
-              <a:rPr lang="en-US"/>
+              <a:rPr lang="en-US" smtClean="0"/>
               <a:t>Click to edit Master text styles</a:t>
             </a:r>
           </a:p>
@@ -3341,7 +3638,7 @@
           <a:p>
             <a:fld id="{5BCAD085-E8A6-8845-BD4E-CB4CCA059FC4}" type="datetimeFigureOut">
               <a:rPr lang="en-US" smtClean="0"/>
-              <a:t>22-Aug-26</a:t>
+              <a:t>1/27/13</a:t>
             </a:fld>
             <a:endParaRPr lang="en-US"/>
           </a:p>
@@ -3450,9 +3747,10 @@
           <a:lstStyle/>
           <a:p>
             <a:r>
-              <a:rPr lang="en-US"/>
+              <a:rPr lang="en-US" smtClean="0"/>
               <a:t>Click to edit Master title style</a:t>
             </a:r>
+            <a:endParaRPr lang="en-US"/>
           </a:p>
         </p:txBody>
       </p:sp>
@@ -3483,37 +3781,38 @@
           <a:p>
             <a:pPr lvl="0"/>
             <a:r>
-              <a:rPr lang="en-US"/>
+              <a:rPr lang="en-US" smtClean="0"/>
               <a:t>Click to edit Master text styles</a:t>
             </a:r>
           </a:p>
           <a:p>
             <a:pPr lvl="1"/>
             <a:r>
-              <a:rPr lang="en-US"/>
+              <a:rPr lang="en-US" smtClean="0"/>
               <a:t>Second level</a:t>
             </a:r>
           </a:p>
           <a:p>
             <a:pPr lvl="2"/>
             <a:r>
-              <a:rPr lang="en-US"/>
+              <a:rPr lang="en-US" smtClean="0"/>
               <a:t>Third level</a:t>
             </a:r>
           </a:p>
           <a:p>
             <a:pPr lvl="3"/>
             <a:r>
-              <a:rPr lang="en-US"/>
+              <a:rPr lang="en-US" smtClean="0"/>
               <a:t>Fourth level</a:t>
             </a:r>
           </a:p>
           <a:p>
             <a:pPr lvl="4"/>
             <a:r>
-              <a:rPr lang="en-US"/>
+              <a:rPr lang="en-US" smtClean="0"/>
               <a:t>Fifth level</a:t>
             </a:r>
+            <a:endParaRPr lang="en-US"/>
           </a:p>
         </p:txBody>
       </p:sp>
@@ -3552,7 +3851,7 @@
           <a:p>
             <a:fld id="{5BCAD085-E8A6-8845-BD4E-CB4CCA059FC4}" type="datetimeFigureOut">
               <a:rPr lang="en-US" smtClean="0"/>
-              <a:t>22-Aug-26</a:t>
+              <a:t>1/27/13</a:t>
             </a:fld>
             <a:endParaRPr lang="en-US"/>
           </a:p>
@@ -3911,7 +4210,7 @@
 </file>
 
 <file path=ppt/slides/slide1.xml><?xml version="1.0" encoding="utf-8"?>
-<p:sld xmlns:a="http://schemas.openxmlformats.org/drawingml/2006/main" xmlns:r="http://schemas.openxmlformats.org/officeDocument/2006/relationships" xmlns:p="http://schemas.openxmlformats.org/presentationml/2006/main">
+<p:sld xmlns:a="http://schemas.openxmlformats.org/drawingml/2006/main" xmlns:p="http://schemas.openxmlformats.org/presentationml/2006/main" xmlns:r="http://schemas.openxmlformats.org/officeDocument/2006/relationships">
   <p:cSld>
     <p:spTree>
       <p:nvGrpSpPr>
@@ -3919,14 +4218,7 @@
         <p:cNvGrpSpPr/>
         <p:nvPr/>
       </p:nvGrpSpPr>
-      <p:grpSpPr>
-        <a:xfrm>
-          <a:off x="0" y="0"/>
-          <a:ext cx="0" cy="0"/>
-          <a:chOff x="0" y="0"/>
-          <a:chExt cx="0" cy="0"/>
-        </a:xfrm>
-      </p:grpSpPr>
+      <p:grpSpPr/>
       <p:sp>
         <p:nvSpPr>
           <p:cNvPr id="2" name="Title 1"/>
@@ -3939,13 +4231,10 @@
         </p:nvSpPr>
         <p:spPr/>
         <p:txBody>
-          <a:bodyPr>
-            <a:normAutofit fontScale="90000"/>
-          </a:bodyPr>
-          <a:lstStyle/>
-          <a:p>
-            <a:r>
-              <a:rPr dirty="0"/>
+          <a:bodyPr/>
+          <a:lstStyle/>
+          <a:p>
+            <a:r>
               <a:t>Deep Reinforcement Learning for Proactive Network Traffic Congestion Control</a:t>
             </a:r>
           </a:p>
@@ -3963,56 +4252,15 @@
         </p:nvSpPr>
         <p:spPr/>
         <p:txBody>
-          <a:bodyPr>
-            <a:normAutofit fontScale="77500" lnSpcReduction="20000"/>
-          </a:bodyPr>
-          <a:lstStyle/>
-          <a:p>
-            <a:r>
-              <a:rPr dirty="0"/>
-              <a:t>Authors: Peter </a:t>
-            </a:r>
-            <a:r>
-              <a:rPr dirty="0" err="1"/>
-              <a:t>Borngreat</a:t>
-            </a:r>
-            <a:r>
-              <a:rPr dirty="0"/>
-              <a:t>-Mensah</a:t>
-            </a:r>
-            <a:r>
-              <a:rPr lang="en-US" dirty="0"/>
-              <a:t> (22424679)</a:t>
-            </a:r>
-            <a:r>
-              <a:rPr dirty="0"/>
-              <a:t>, Henry Asante</a:t>
-            </a:r>
-            <a:r>
-              <a:rPr lang="en-US" dirty="0"/>
-              <a:t> (22424186)</a:t>
-            </a:r>
-            <a:r>
-              <a:rPr dirty="0"/>
-              <a:t>, Blessing </a:t>
-            </a:r>
-            <a:r>
-              <a:rPr dirty="0" err="1"/>
-              <a:t>Listowell</a:t>
-            </a:r>
-            <a:r>
-              <a:rPr dirty="0"/>
-              <a:t> Issaka</a:t>
-            </a:r>
-            <a:r>
-              <a:rPr lang="en-US" dirty="0"/>
-              <a:t> (22424754)</a:t>
-            </a:r>
-            <a:endParaRPr dirty="0"/>
-          </a:p>
-          <a:p>
-            <a:r>
-              <a:rPr dirty="0"/>
+          <a:bodyPr/>
+          <a:lstStyle/>
+          <a:p>
+            <a:r>
+              <a:t>Authors: Peter Borngreat-Mensah, Henry Asante, Blessing Listowell Issaka</a:t>
+            </a:r>
+          </a:p>
+          <a:p>
+            <a:r>
               <a:t>MSc Computer Science, Cohort B, University of Ghana</a:t>
             </a:r>
           </a:p>
@@ -4027,7 +4275,7 @@
 </file>
 
 <file path=ppt/slides/slide10.xml><?xml version="1.0" encoding="utf-8"?>
-<p:sld xmlns:a="http://schemas.openxmlformats.org/drawingml/2006/main" xmlns:r="http://schemas.openxmlformats.org/officeDocument/2006/relationships" xmlns:p="http://schemas.openxmlformats.org/presentationml/2006/main">
+<p:sld xmlns:a="http://schemas.openxmlformats.org/drawingml/2006/main" xmlns:p="http://schemas.openxmlformats.org/presentationml/2006/main" xmlns:r="http://schemas.openxmlformats.org/officeDocument/2006/relationships">
   <p:cSld>
     <p:spTree>
       <p:nvGrpSpPr>
@@ -4035,14 +4283,7 @@
         <p:cNvGrpSpPr/>
         <p:nvPr/>
       </p:nvGrpSpPr>
-      <p:grpSpPr>
-        <a:xfrm>
-          <a:off x="0" y="0"/>
-          <a:ext cx="0" cy="0"/>
-          <a:chOff x="0" y="0"/>
-          <a:chExt cx="0" cy="0"/>
-        </a:xfrm>
-      </p:grpSpPr>
+      <p:grpSpPr/>
       <p:sp>
         <p:nvSpPr>
           <p:cNvPr id="2" name="Title 1"/>
@@ -4059,257 +4300,7 @@
           <a:lstStyle/>
           <a:p>
             <a:r>
-              <a:t>Conclusion &amp; Future Work</a:t>
-            </a:r>
-          </a:p>
-        </p:txBody>
-      </p:sp>
-      <p:sp>
-        <p:nvSpPr>
-          <p:cNvPr id="3" name="Content Placeholder 2"/>
-          <p:cNvSpPr>
-            <a:spLocks noGrp="1"/>
-          </p:cNvSpPr>
-          <p:nvPr>
-            <p:ph idx="1"/>
-          </p:nvPr>
-        </p:nvSpPr>
-        <p:spPr/>
-        <p:txBody>
-          <a:bodyPr/>
-          <a:lstStyle/>
-          <a:p>
-            <a:r>
-              <a:t>- DRL (specifically PPO) is highly viable for proactive micro-burst load balancing.</a:t>
-            </a:r>
-          </a:p>
-          <a:p>
-            <a:r>
-              <a:t>- Zero-shot generalization is achievable via topological state vector zero-padding.</a:t>
-            </a:r>
-          </a:p>
-          <a:p>
-            <a:r>
-              <a:t>- DRL cannot solve absolute network saturation.</a:t>
-            </a:r>
-          </a:p>
-          <a:p>
-            <a:r>
-              <a:t>- Future Work: Coupling DRL routing with dynamic admission control.</a:t>
-            </a:r>
-          </a:p>
-        </p:txBody>
-      </p:sp>
-    </p:spTree>
-  </p:cSld>
-  <p:clrMapOvr>
-    <a:masterClrMapping/>
-  </p:clrMapOvr>
-</p:sld>
-</file>
-
-<file path=ppt/slides/slide2.xml><?xml version="1.0" encoding="utf-8"?>
-<p:sld xmlns:a="http://schemas.openxmlformats.org/drawingml/2006/main" xmlns:r="http://schemas.openxmlformats.org/officeDocument/2006/relationships" xmlns:p="http://schemas.openxmlformats.org/presentationml/2006/main">
-  <p:cSld>
-    <p:spTree>
-      <p:nvGrpSpPr>
-        <p:cNvPr id="1" name=""/>
-        <p:cNvGrpSpPr/>
-        <p:nvPr/>
-      </p:nvGrpSpPr>
-      <p:grpSpPr>
-        <a:xfrm>
-          <a:off x="0" y="0"/>
-          <a:ext cx="0" cy="0"/>
-          <a:chOff x="0" y="0"/>
-          <a:chExt cx="0" cy="0"/>
-        </a:xfrm>
-      </p:grpSpPr>
-      <p:sp>
-        <p:nvSpPr>
-          <p:cNvPr id="2" name="Title 1"/>
-          <p:cNvSpPr>
-            <a:spLocks noGrp="1"/>
-          </p:cNvSpPr>
-          <p:nvPr>
-            <p:ph type="title"/>
-          </p:nvPr>
-        </p:nvSpPr>
-        <p:spPr/>
-        <p:txBody>
-          <a:bodyPr>
-            <a:normAutofit fontScale="90000"/>
-          </a:bodyPr>
-          <a:lstStyle/>
-          <a:p>
-            <a:r>
-              <a:t>The Problem: Static Routing &amp; Micro-Bursts</a:t>
-            </a:r>
-          </a:p>
-        </p:txBody>
-      </p:sp>
-      <p:sp>
-        <p:nvSpPr>
-          <p:cNvPr id="3" name="Content Placeholder 2"/>
-          <p:cNvSpPr>
-            <a:spLocks noGrp="1"/>
-          </p:cNvSpPr>
-          <p:nvPr>
-            <p:ph idx="1"/>
-          </p:nvPr>
-        </p:nvSpPr>
-        <p:spPr/>
-        <p:txBody>
-          <a:bodyPr/>
-          <a:lstStyle/>
-          <a:p>
-            <a:r>
-              <a:t>- Wide-area networks experience heavy volatility.</a:t>
-            </a:r>
-          </a:p>
-          <a:p>
-            <a:r>
-              <a:t>- Equal-Cost Multi-Path (ECMP) relies on static hashing.</a:t>
-            </a:r>
-          </a:p>
-          <a:p>
-            <a:r>
-              <a:t>- ECMP is blind to real-time telemetry.</a:t>
-            </a:r>
-          </a:p>
-          <a:p>
-            <a:r>
-              <a:t>- 'Elephant flows' collide on bottleneck links.</a:t>
-            </a:r>
-          </a:p>
-        </p:txBody>
-      </p:sp>
-    </p:spTree>
-  </p:cSld>
-  <p:clrMapOvr>
-    <a:masterClrMapping/>
-  </p:clrMapOvr>
-</p:sld>
-</file>
-
-<file path=ppt/slides/slide3.xml><?xml version="1.0" encoding="utf-8"?>
-<p:sld xmlns:a="http://schemas.openxmlformats.org/drawingml/2006/main" xmlns:r="http://schemas.openxmlformats.org/officeDocument/2006/relationships" xmlns:p="http://schemas.openxmlformats.org/presentationml/2006/main">
-  <p:cSld>
-    <p:spTree>
-      <p:nvGrpSpPr>
-        <p:cNvPr id="1" name=""/>
-        <p:cNvGrpSpPr/>
-        <p:nvPr/>
-      </p:nvGrpSpPr>
-      <p:grpSpPr>
-        <a:xfrm>
-          <a:off x="0" y="0"/>
-          <a:ext cx="0" cy="0"/>
-          <a:chOff x="0" y="0"/>
-          <a:chExt cx="0" cy="0"/>
-        </a:xfrm>
-      </p:grpSpPr>
-      <p:sp>
-        <p:nvSpPr>
-          <p:cNvPr id="2" name="Title 1"/>
-          <p:cNvSpPr>
-            <a:spLocks noGrp="1"/>
-          </p:cNvSpPr>
-          <p:nvPr>
-            <p:ph type="title"/>
-          </p:nvPr>
-        </p:nvSpPr>
-        <p:spPr/>
-        <p:txBody>
-          <a:bodyPr/>
-          <a:lstStyle/>
-          <a:p>
-            <a:r>
-              <a:t>Research Objectives</a:t>
-            </a:r>
-          </a:p>
-        </p:txBody>
-      </p:sp>
-      <p:sp>
-        <p:nvSpPr>
-          <p:cNvPr id="3" name="Content Placeholder 2"/>
-          <p:cNvSpPr>
-            <a:spLocks noGrp="1"/>
-          </p:cNvSpPr>
-          <p:nvPr>
-            <p:ph idx="1"/>
-          </p:nvPr>
-        </p:nvSpPr>
-        <p:spPr/>
-        <p:txBody>
-          <a:bodyPr/>
-          <a:lstStyle/>
-          <a:p>
-            <a:r>
-              <a:t>1. Evaluate Deep Reinforcement Learning (DQN, PPO).</a:t>
-            </a:r>
-          </a:p>
-          <a:p>
-            <a:r>
-              <a:t>2. Implement intelligent agents within an SDN framework.</a:t>
-            </a:r>
-          </a:p>
-          <a:p>
-            <a:r>
-              <a:t>3. Critically test Zero-Shot Generalization on unseen topologies.</a:t>
-            </a:r>
-          </a:p>
-          <a:p>
-            <a:r>
-              <a:t>4. Discover limitations under heavy network saturation.</a:t>
-            </a:r>
-          </a:p>
-        </p:txBody>
-      </p:sp>
-    </p:spTree>
-  </p:cSld>
-  <p:clrMapOvr>
-    <a:masterClrMapping/>
-  </p:clrMapOvr>
-</p:sld>
-</file>
-
-<file path=ppt/slides/slide4.xml><?xml version="1.0" encoding="utf-8"?>
-<p:sld xmlns:a="http://schemas.openxmlformats.org/drawingml/2006/main" xmlns:r="http://schemas.openxmlformats.org/officeDocument/2006/relationships" xmlns:p="http://schemas.openxmlformats.org/presentationml/2006/main">
-  <p:cSld>
-    <p:spTree>
-      <p:nvGrpSpPr>
-        <p:cNvPr id="1" name=""/>
-        <p:cNvGrpSpPr/>
-        <p:nvPr/>
-      </p:nvGrpSpPr>
-      <p:grpSpPr>
-        <a:xfrm>
-          <a:off x="0" y="0"/>
-          <a:ext cx="0" cy="0"/>
-          <a:chOff x="0" y="0"/>
-          <a:chExt cx="0" cy="0"/>
-        </a:xfrm>
-      </p:grpSpPr>
-      <p:sp>
-        <p:nvSpPr>
-          <p:cNvPr id="2" name="Title 1"/>
-          <p:cNvSpPr>
-            <a:spLocks noGrp="1"/>
-          </p:cNvSpPr>
-          <p:nvPr>
-            <p:ph type="title"/>
-          </p:nvPr>
-        </p:nvSpPr>
-        <p:spPr/>
-        <p:txBody>
-          <a:bodyPr>
-            <a:normAutofit fontScale="90000"/>
-          </a:bodyPr>
-          <a:lstStyle/>
-          <a:p>
-            <a:r>
-              <a:t>Methodology: State Space &amp; PCA Features</a:t>
+              <a:t>Zero-Shot Generalization vs Network Size</a:t>
             </a:r>
           </a:p>
         </p:txBody>
@@ -4337,6 +4328,404 @@
           <a:lstStyle/>
           <a:p>
             <a:r>
+              <a:t>- Agents tested on 5 UNSEEN Topologies.</a:t>
+            </a:r>
+          </a:p>
+          <a:p>
+            <a:r>
+              <a:t>- Performance decays naturally as nodes increase.</a:t>
+            </a:r>
+          </a:p>
+          <a:p>
+            <a:r>
+              <a:t>- PPO maintains superior trajectory over DQN.</a:t>
+            </a:r>
+          </a:p>
+        </p:txBody>
+      </p:sp>
+    </p:spTree>
+  </p:cSld>
+  <p:clrMapOvr>
+    <a:masterClrMapping/>
+  </p:clrMapOvr>
+</p:sld>
+</file>
+
+<file path=ppt/slides/slide11.xml><?xml version="1.0" encoding="utf-8"?>
+<p:sld xmlns:a="http://schemas.openxmlformats.org/drawingml/2006/main" xmlns:p="http://schemas.openxmlformats.org/presentationml/2006/main" xmlns:r="http://schemas.openxmlformats.org/officeDocument/2006/relationships">
+  <p:cSld>
+    <p:spTree>
+      <p:nvGrpSpPr>
+        <p:cNvPr id="1" name=""/>
+        <p:cNvGrpSpPr/>
+        <p:nvPr/>
+      </p:nvGrpSpPr>
+      <p:grpSpPr/>
+      <p:sp>
+        <p:nvSpPr>
+          <p:cNvPr id="2" name="Title 1"/>
+          <p:cNvSpPr>
+            <a:spLocks noGrp="1"/>
+          </p:cNvSpPr>
+          <p:nvPr>
+            <p:ph type="title"/>
+          </p:nvPr>
+        </p:nvSpPr>
+        <p:spPr/>
+        <p:txBody>
+          <a:bodyPr/>
+          <a:lstStyle/>
+          <a:p>
+            <a:r>
+              <a:t>Variance and Predictability</a:t>
+            </a:r>
+          </a:p>
+        </p:txBody>
+      </p:sp>
+      <p:sp>
+        <p:nvSpPr>
+          <p:cNvPr id="3" name="TextBox 2"/>
+          <p:cNvSpPr txBox="1"/>
+          <p:nvPr/>
+        </p:nvSpPr>
+        <p:spPr>
+          <a:xfrm>
+            <a:off x="457200" y="1371600"/>
+            <a:ext cx="3657600" cy="3657600"/>
+          </a:xfrm>
+          <a:prstGeom prst="rect">
+            <a:avLst/>
+          </a:prstGeom>
+          <a:noFill/>
+        </p:spPr>
+        <p:txBody>
+          <a:bodyPr wrap="none">
+            <a:spAutoFit/>
+          </a:bodyPr>
+          <a:lstStyle/>
+          <a:p>
+            <a:r>
+              <a:t>- ECMP provides narrow, predictable variance.</a:t>
+            </a:r>
+          </a:p>
+          <a:p>
+            <a:r>
+              <a:t>- DRL trades predictability for aggressive reaction to bursts.</a:t>
+            </a:r>
+          </a:p>
+        </p:txBody>
+      </p:sp>
+      <p:pic>
+        <p:nvPicPr>
+          <p:cNvPr id="4" name="Picture 3" descr="congestion_violin.png"/>
+          <p:cNvPicPr>
+            <a:picLocks noChangeAspect="1"/>
+          </p:cNvPicPr>
+          <p:nvPr/>
+        </p:nvPicPr>
+        <p:blipFill>
+          <a:blip r:embed="rId2"/>
+          <a:stretch>
+            <a:fillRect/>
+          </a:stretch>
+        </p:blipFill>
+        <p:spPr>
+          <a:xfrm>
+            <a:off x="4114800" y="1828800"/>
+            <a:ext cx="4572000" cy="2743200"/>
+          </a:xfrm>
+          <a:prstGeom prst="rect">
+            <a:avLst/>
+          </a:prstGeom>
+        </p:spPr>
+      </p:pic>
+    </p:spTree>
+  </p:cSld>
+  <p:clrMapOvr>
+    <a:masterClrMapping/>
+  </p:clrMapOvr>
+</p:sld>
+</file>
+
+<file path=ppt/slides/slide12.xml><?xml version="1.0" encoding="utf-8"?>
+<p:sld xmlns:a="http://schemas.openxmlformats.org/drawingml/2006/main" xmlns:p="http://schemas.openxmlformats.org/presentationml/2006/main" xmlns:r="http://schemas.openxmlformats.org/officeDocument/2006/relationships">
+  <p:cSld>
+    <p:spTree>
+      <p:nvGrpSpPr>
+        <p:cNvPr id="1" name=""/>
+        <p:cNvGrpSpPr/>
+        <p:nvPr/>
+      </p:nvGrpSpPr>
+      <p:grpSpPr/>
+      <p:sp>
+        <p:nvSpPr>
+          <p:cNvPr id="2" name="Title 1"/>
+          <p:cNvSpPr>
+            <a:spLocks noGrp="1"/>
+          </p:cNvSpPr>
+          <p:nvPr>
+            <p:ph type="title"/>
+          </p:nvPr>
+        </p:nvSpPr>
+        <p:spPr/>
+        <p:txBody>
+          <a:bodyPr/>
+          <a:lstStyle/>
+          <a:p>
+            <a:r>
+              <a:t>Conclusion &amp; Future Work</a:t>
+            </a:r>
+          </a:p>
+        </p:txBody>
+      </p:sp>
+      <p:sp>
+        <p:nvSpPr>
+          <p:cNvPr id="3" name="Content Placeholder 2"/>
+          <p:cNvSpPr>
+            <a:spLocks noGrp="1"/>
+          </p:cNvSpPr>
+          <p:nvPr>
+            <p:ph idx="1"/>
+          </p:nvPr>
+        </p:nvSpPr>
+        <p:spPr/>
+        <p:txBody>
+          <a:bodyPr/>
+          <a:lstStyle/>
+          <a:p>
+            <a:r>
+              <a:t>- DRL (specifically PPO) is highly viable for proactive micro-burst load balancing.</a:t>
+            </a:r>
+          </a:p>
+          <a:p>
+            <a:r>
+              <a:t>- Zero-shot generalization is achievable via topological state vector zero-padding.</a:t>
+            </a:r>
+          </a:p>
+          <a:p>
+            <a:r>
+              <a:t>- DRL cannot solve absolute network saturation.</a:t>
+            </a:r>
+          </a:p>
+          <a:p>
+            <a:r>
+              <a:t>- Future Work: Coupling DRL routing with dynamic admission control.</a:t>
+            </a:r>
+          </a:p>
+        </p:txBody>
+      </p:sp>
+    </p:spTree>
+  </p:cSld>
+  <p:clrMapOvr>
+    <a:masterClrMapping/>
+  </p:clrMapOvr>
+</p:sld>
+</file>
+
+<file path=ppt/slides/slide2.xml><?xml version="1.0" encoding="utf-8"?>
+<p:sld xmlns:a="http://schemas.openxmlformats.org/drawingml/2006/main" xmlns:p="http://schemas.openxmlformats.org/presentationml/2006/main" xmlns:r="http://schemas.openxmlformats.org/officeDocument/2006/relationships">
+  <p:cSld>
+    <p:spTree>
+      <p:nvGrpSpPr>
+        <p:cNvPr id="1" name=""/>
+        <p:cNvGrpSpPr/>
+        <p:nvPr/>
+      </p:nvGrpSpPr>
+      <p:grpSpPr/>
+      <p:sp>
+        <p:nvSpPr>
+          <p:cNvPr id="2" name="Title 1"/>
+          <p:cNvSpPr>
+            <a:spLocks noGrp="1"/>
+          </p:cNvSpPr>
+          <p:nvPr>
+            <p:ph type="title"/>
+          </p:nvPr>
+        </p:nvSpPr>
+        <p:spPr/>
+        <p:txBody>
+          <a:bodyPr/>
+          <a:lstStyle/>
+          <a:p>
+            <a:r>
+              <a:t>The Problem: Static Routing &amp; Micro-Bursts</a:t>
+            </a:r>
+          </a:p>
+        </p:txBody>
+      </p:sp>
+      <p:sp>
+        <p:nvSpPr>
+          <p:cNvPr id="3" name="Content Placeholder 2"/>
+          <p:cNvSpPr>
+            <a:spLocks noGrp="1"/>
+          </p:cNvSpPr>
+          <p:nvPr>
+            <p:ph idx="1"/>
+          </p:nvPr>
+        </p:nvSpPr>
+        <p:spPr/>
+        <p:txBody>
+          <a:bodyPr/>
+          <a:lstStyle/>
+          <a:p>
+            <a:r>
+              <a:t>- Wide-area networks experience heavy volatility.</a:t>
+            </a:r>
+          </a:p>
+          <a:p>
+            <a:r>
+              <a:t>- Equal-Cost Multi-Path (ECMP) relies on static hashing.</a:t>
+            </a:r>
+          </a:p>
+          <a:p>
+            <a:r>
+              <a:t>- ECMP is blind to real-time telemetry.</a:t>
+            </a:r>
+          </a:p>
+          <a:p>
+            <a:r>
+              <a:t>- 'Elephant flows' collide on bottleneck links.</a:t>
+            </a:r>
+          </a:p>
+        </p:txBody>
+      </p:sp>
+    </p:spTree>
+  </p:cSld>
+  <p:clrMapOvr>
+    <a:masterClrMapping/>
+  </p:clrMapOvr>
+</p:sld>
+</file>
+
+<file path=ppt/slides/slide3.xml><?xml version="1.0" encoding="utf-8"?>
+<p:sld xmlns:a="http://schemas.openxmlformats.org/drawingml/2006/main" xmlns:p="http://schemas.openxmlformats.org/presentationml/2006/main" xmlns:r="http://schemas.openxmlformats.org/officeDocument/2006/relationships">
+  <p:cSld>
+    <p:spTree>
+      <p:nvGrpSpPr>
+        <p:cNvPr id="1" name=""/>
+        <p:cNvGrpSpPr/>
+        <p:nvPr/>
+      </p:nvGrpSpPr>
+      <p:grpSpPr/>
+      <p:sp>
+        <p:nvSpPr>
+          <p:cNvPr id="2" name="Title 1"/>
+          <p:cNvSpPr>
+            <a:spLocks noGrp="1"/>
+          </p:cNvSpPr>
+          <p:nvPr>
+            <p:ph type="title"/>
+          </p:nvPr>
+        </p:nvSpPr>
+        <p:spPr/>
+        <p:txBody>
+          <a:bodyPr/>
+          <a:lstStyle/>
+          <a:p>
+            <a:r>
+              <a:t>Research Objectives</a:t>
+            </a:r>
+          </a:p>
+        </p:txBody>
+      </p:sp>
+      <p:sp>
+        <p:nvSpPr>
+          <p:cNvPr id="3" name="Content Placeholder 2"/>
+          <p:cNvSpPr>
+            <a:spLocks noGrp="1"/>
+          </p:cNvSpPr>
+          <p:nvPr>
+            <p:ph idx="1"/>
+          </p:nvPr>
+        </p:nvSpPr>
+        <p:spPr/>
+        <p:txBody>
+          <a:bodyPr/>
+          <a:lstStyle/>
+          <a:p>
+            <a:r>
+              <a:t>1. Evaluate Deep Reinforcement Learning (DQN, PPO).</a:t>
+            </a:r>
+          </a:p>
+          <a:p>
+            <a:r>
+              <a:t>2. Implement intelligent agents within an SDN framework.</a:t>
+            </a:r>
+          </a:p>
+          <a:p>
+            <a:r>
+              <a:t>3. Critically test Zero-Shot Generalization on unseen topologies.</a:t>
+            </a:r>
+          </a:p>
+          <a:p>
+            <a:r>
+              <a:t>4. Discover limitations under heavy network saturation.</a:t>
+            </a:r>
+          </a:p>
+        </p:txBody>
+      </p:sp>
+    </p:spTree>
+  </p:cSld>
+  <p:clrMapOvr>
+    <a:masterClrMapping/>
+  </p:clrMapOvr>
+</p:sld>
+</file>
+
+<file path=ppt/slides/slide4.xml><?xml version="1.0" encoding="utf-8"?>
+<p:sld xmlns:a="http://schemas.openxmlformats.org/drawingml/2006/main" xmlns:p="http://schemas.openxmlformats.org/presentationml/2006/main" xmlns:r="http://schemas.openxmlformats.org/officeDocument/2006/relationships">
+  <p:cSld>
+    <p:spTree>
+      <p:nvGrpSpPr>
+        <p:cNvPr id="1" name=""/>
+        <p:cNvGrpSpPr/>
+        <p:nvPr/>
+      </p:nvGrpSpPr>
+      <p:grpSpPr/>
+      <p:sp>
+        <p:nvSpPr>
+          <p:cNvPr id="2" name="Title 1"/>
+          <p:cNvSpPr>
+            <a:spLocks noGrp="1"/>
+          </p:cNvSpPr>
+          <p:nvPr>
+            <p:ph type="title"/>
+          </p:nvPr>
+        </p:nvSpPr>
+        <p:spPr/>
+        <p:txBody>
+          <a:bodyPr/>
+          <a:lstStyle/>
+          <a:p>
+            <a:r>
+              <a:t>Methodology: State Space &amp; PCA Features</a:t>
+            </a:r>
+          </a:p>
+        </p:txBody>
+      </p:sp>
+      <p:sp>
+        <p:nvSpPr>
+          <p:cNvPr id="3" name="TextBox 2"/>
+          <p:cNvSpPr txBox="1"/>
+          <p:nvPr/>
+        </p:nvSpPr>
+        <p:spPr>
+          <a:xfrm>
+            <a:off x="457200" y="1371600"/>
+            <a:ext cx="3657600" cy="3657600"/>
+          </a:xfrm>
+          <a:prstGeom prst="rect">
+            <a:avLst/>
+          </a:prstGeom>
+          <a:noFill/>
+        </p:spPr>
+        <p:txBody>
+          <a:bodyPr wrap="none">
+            <a:spAutoFit/>
+          </a:bodyPr>
+          <a:lstStyle/>
+          <a:p>
+            <a:r>
               <a:t>- 250-dimensional continuous vector.</a:t>
             </a:r>
           </a:p>
@@ -4371,14 +4760,14 @@
           <p:nvPr/>
         </p:nvPicPr>
         <p:blipFill>
-          <a:blip r:embed="rId3"/>
+          <a:blip r:embed="rId2"/>
           <a:stretch>
             <a:fillRect/>
           </a:stretch>
         </p:blipFill>
         <p:spPr>
           <a:xfrm>
-            <a:off x="2206305" y="3280095"/>
+            <a:off x="4114800" y="1828800"/>
             <a:ext cx="4572000" cy="2302643"/>
           </a:xfrm>
           <a:prstGeom prst="rect">
@@ -4395,7 +4784,7 @@
 </file>
 
 <file path=ppt/slides/slide5.xml><?xml version="1.0" encoding="utf-8"?>
-<p:sld xmlns:a="http://schemas.openxmlformats.org/drawingml/2006/main" xmlns:r="http://schemas.openxmlformats.org/officeDocument/2006/relationships" xmlns:p="http://schemas.openxmlformats.org/presentationml/2006/main">
+<p:sld xmlns:a="http://schemas.openxmlformats.org/drawingml/2006/main" xmlns:p="http://schemas.openxmlformats.org/presentationml/2006/main" xmlns:r="http://schemas.openxmlformats.org/officeDocument/2006/relationships">
   <p:cSld>
     <p:spTree>
       <p:nvGrpSpPr>
@@ -4403,14 +4792,7 @@
         <p:cNvGrpSpPr/>
         <p:nvPr/>
       </p:nvGrpSpPr>
-      <p:grpSpPr>
-        <a:xfrm>
-          <a:off x="0" y="0"/>
-          <a:ext cx="0" cy="0"/>
-          <a:chOff x="0" y="0"/>
-          <a:chExt cx="0" cy="0"/>
-        </a:xfrm>
-      </p:grpSpPr>
+      <p:grpSpPr/>
       <p:sp>
         <p:nvSpPr>
           <p:cNvPr id="2" name="Title 1"/>
@@ -4423,9 +4805,7 @@
         </p:nvSpPr>
         <p:spPr/>
         <p:txBody>
-          <a:bodyPr>
-            <a:normAutofit fontScale="90000"/>
-          </a:bodyPr>
+          <a:bodyPr/>
           <a:lstStyle/>
           <a:p>
             <a:r>
@@ -4481,14 +4861,14 @@
           <p:nvPr/>
         </p:nvPicPr>
         <p:blipFill>
-          <a:blip r:embed="rId3"/>
+          <a:blip r:embed="rId2"/>
           <a:stretch>
             <a:fillRect/>
           </a:stretch>
         </p:blipFill>
         <p:spPr>
           <a:xfrm>
-            <a:off x="1732327" y="2546059"/>
+            <a:off x="4114800" y="1828800"/>
             <a:ext cx="4572000" cy="3101641"/>
           </a:xfrm>
           <a:prstGeom prst="rect">
@@ -4505,7 +4885,7 @@
 </file>
 
 <file path=ppt/slides/slide6.xml><?xml version="1.0" encoding="utf-8"?>
-<p:sld xmlns:a="http://schemas.openxmlformats.org/drawingml/2006/main" xmlns:r="http://schemas.openxmlformats.org/officeDocument/2006/relationships" xmlns:p="http://schemas.openxmlformats.org/presentationml/2006/main">
+<p:sld xmlns:a="http://schemas.openxmlformats.org/drawingml/2006/main" xmlns:p="http://schemas.openxmlformats.org/presentationml/2006/main" xmlns:r="http://schemas.openxmlformats.org/officeDocument/2006/relationships">
   <p:cSld>
     <p:spTree>
       <p:nvGrpSpPr>
@@ -4513,14 +4893,7 @@
         <p:cNvGrpSpPr/>
         <p:nvPr/>
       </p:nvGrpSpPr>
-      <p:grpSpPr>
-        <a:xfrm>
-          <a:off x="0" y="0"/>
-          <a:ext cx="0" cy="0"/>
-          <a:chOff x="0" y="0"/>
-          <a:chExt cx="0" cy="0"/>
-        </a:xfrm>
-      </p:grpSpPr>
+      <p:grpSpPr/>
       <p:sp>
         <p:nvSpPr>
           <p:cNvPr id="2" name="Title 1"/>
@@ -4575,6 +4948,91 @@
           </a:p>
         </p:txBody>
       </p:sp>
+    </p:spTree>
+  </p:cSld>
+  <p:clrMapOvr>
+    <a:masterClrMapping/>
+  </p:clrMapOvr>
+</p:sld>
+</file>
+
+<file path=ppt/slides/slide7.xml><?xml version="1.0" encoding="utf-8"?>
+<p:sld xmlns:a="http://schemas.openxmlformats.org/drawingml/2006/main" xmlns:p="http://schemas.openxmlformats.org/presentationml/2006/main" xmlns:r="http://schemas.openxmlformats.org/officeDocument/2006/relationships">
+  <p:cSld>
+    <p:spTree>
+      <p:nvGrpSpPr>
+        <p:cNvPr id="1" name=""/>
+        <p:cNvGrpSpPr/>
+        <p:nvPr/>
+      </p:nvGrpSpPr>
+      <p:grpSpPr/>
+      <p:sp>
+        <p:nvSpPr>
+          <p:cNvPr id="2" name="Title 1"/>
+          <p:cNvSpPr>
+            <a:spLocks noGrp="1"/>
+          </p:cNvSpPr>
+          <p:nvPr>
+            <p:ph type="title"/>
+          </p:nvPr>
+        </p:nvSpPr>
+        <p:spPr/>
+        <p:txBody>
+          <a:bodyPr/>
+          <a:lstStyle/>
+          <a:p>
+            <a:r>
+              <a:t>Superior Performance under Moderate Traffic</a:t>
+            </a:r>
+          </a:p>
+        </p:txBody>
+      </p:sp>
+      <p:sp>
+        <p:nvSpPr>
+          <p:cNvPr id="3" name="TextBox 2"/>
+          <p:cNvSpPr txBox="1"/>
+          <p:nvPr/>
+        </p:nvSpPr>
+        <p:spPr>
+          <a:xfrm>
+            <a:off x="457200" y="1371600"/>
+            <a:ext cx="4114800" cy="4572000"/>
+          </a:xfrm>
+          <a:prstGeom prst="rect">
+            <a:avLst/>
+          </a:prstGeom>
+          <a:noFill/>
+        </p:spPr>
+        <p:txBody>
+          <a:bodyPr wrap="none">
+            <a:spAutoFit/>
+          </a:bodyPr>
+          <a:lstStyle/>
+          <a:p>
+            <a:r>
+              <a:t>Optimal Operating Window:</a:t>
+            </a:r>
+          </a:p>
+          <a:p>
+            <a:pPr lvl="1"/>
+            <a:r>
+              <a:t>- Under moderate traffic conditions, both DQN and PPO consistently outperformed traditional ECMP.</a:t>
+            </a:r>
+          </a:p>
+          <a:p>
+            <a:pPr lvl="1"/>
+            <a:r>
+              <a:t>- Achieved lower congestion penalties and higher overall throughput.</a:t>
+            </a:r>
+          </a:p>
+          <a:p>
+            <a:pPr lvl="1"/>
+            <a:r>
+              <a:t>- The models learned to proactively divert traffic to sub-optimal but empty paths.</a:t>
+            </a:r>
+          </a:p>
+        </p:txBody>
+      </p:sp>
       <p:pic>
         <p:nvPicPr>
           <p:cNvPr id="4" name="Picture 3" descr="burst_performance_bar.png"/>
@@ -4584,125 +5042,15 @@
           <p:nvPr/>
         </p:nvPicPr>
         <p:blipFill>
-          <a:blip r:embed="rId3"/>
+          <a:blip r:embed="rId2"/>
           <a:stretch>
             <a:fillRect/>
           </a:stretch>
         </p:blipFill>
         <p:spPr>
           <a:xfrm>
-            <a:off x="717258" y="2256639"/>
-            <a:ext cx="7315200" cy="3381555"/>
-          </a:xfrm>
-          <a:prstGeom prst="rect">
-            <a:avLst/>
-          </a:prstGeom>
-        </p:spPr>
-      </p:pic>
-    </p:spTree>
-  </p:cSld>
-  <p:clrMapOvr>
-    <a:masterClrMapping/>
-  </p:clrMapOvr>
-</p:sld>
-</file>
-
-<file path=ppt/slides/slide7.xml><?xml version="1.0" encoding="utf-8"?>
-<p:sld xmlns:a="http://schemas.openxmlformats.org/drawingml/2006/main" xmlns:r="http://schemas.openxmlformats.org/officeDocument/2006/relationships" xmlns:p="http://schemas.openxmlformats.org/presentationml/2006/main">
-  <p:cSld>
-    <p:spTree>
-      <p:nvGrpSpPr>
-        <p:cNvPr id="1" name=""/>
-        <p:cNvGrpSpPr/>
-        <p:nvPr/>
-      </p:nvGrpSpPr>
-      <p:grpSpPr>
-        <a:xfrm>
-          <a:off x="0" y="0"/>
-          <a:ext cx="0" cy="0"/>
-          <a:chOff x="0" y="0"/>
-          <a:chExt cx="0" cy="0"/>
-        </a:xfrm>
-      </p:grpSpPr>
-      <p:sp>
-        <p:nvSpPr>
-          <p:cNvPr id="2" name="Title 1"/>
-          <p:cNvSpPr>
-            <a:spLocks noGrp="1"/>
-          </p:cNvSpPr>
-          <p:nvPr>
-            <p:ph type="title"/>
-          </p:nvPr>
-        </p:nvSpPr>
-        <p:spPr/>
-        <p:txBody>
-          <a:bodyPr>
-            <a:normAutofit fontScale="90000"/>
-          </a:bodyPr>
-          <a:lstStyle/>
-          <a:p>
-            <a:r>
-              <a:t>The Saturation Limit (Honest Negative Result)</a:t>
-            </a:r>
-          </a:p>
-        </p:txBody>
-      </p:sp>
-      <p:sp>
-        <p:nvSpPr>
-          <p:cNvPr id="3" name="TextBox 2"/>
-          <p:cNvSpPr txBox="1"/>
-          <p:nvPr/>
-        </p:nvSpPr>
-        <p:spPr>
-          <a:xfrm>
-            <a:off x="457200" y="1371600"/>
-            <a:ext cx="3657600" cy="3657600"/>
-          </a:xfrm>
-          <a:prstGeom prst="rect">
-            <a:avLst/>
-          </a:prstGeom>
-          <a:noFill/>
-        </p:spPr>
-        <p:txBody>
-          <a:bodyPr wrap="none">
-            <a:spAutoFit/>
-          </a:bodyPr>
-          <a:lstStyle/>
-          <a:p>
-            <a:r>
-              <a:t>- Extreme congestion mathematically saturates the network.</a:t>
-            </a:r>
-          </a:p>
-          <a:p>
-            <a:r>
-              <a:t>- No routing policy can create bandwidth.</a:t>
-            </a:r>
-          </a:p>
-          <a:p>
-            <a:r>
-              <a:t>- DRL performs identically/worse than ECMP here.</a:t>
-            </a:r>
-          </a:p>
-        </p:txBody>
-      </p:sp>
-      <p:pic>
-        <p:nvPicPr>
-          <p:cNvPr id="4" name="Picture 3" descr="throughput_vs_latency.png"/>
-          <p:cNvPicPr>
-            <a:picLocks noChangeAspect="1"/>
-          </p:cNvPicPr>
-          <p:nvPr/>
-        </p:nvPicPr>
-        <p:blipFill>
-          <a:blip r:embed="rId3"/>
-          <a:stretch>
-            <a:fillRect/>
-          </a:stretch>
-        </p:blipFill>
-        <p:spPr>
-          <a:xfrm>
-            <a:off x="1761688" y="2306972"/>
-            <a:ext cx="4572000" cy="3657600"/>
+            <a:off x="4572000" y="1371600"/>
+            <a:ext cx="4114800" cy="2057400"/>
           </a:xfrm>
           <a:prstGeom prst="rect">
             <a:avLst/>
@@ -4718,7 +5066,7 @@
 </file>
 
 <file path=ppt/slides/slide8.xml><?xml version="1.0" encoding="utf-8"?>
-<p:sld xmlns:a="http://schemas.openxmlformats.org/drawingml/2006/main" xmlns:r="http://schemas.openxmlformats.org/officeDocument/2006/relationships" xmlns:p="http://schemas.openxmlformats.org/presentationml/2006/main">
+<p:sld xmlns:a="http://schemas.openxmlformats.org/drawingml/2006/main" xmlns:p="http://schemas.openxmlformats.org/presentationml/2006/main" xmlns:r="http://schemas.openxmlformats.org/officeDocument/2006/relationships">
   <p:cSld>
     <p:spTree>
       <p:nvGrpSpPr>
@@ -4726,14 +5074,7 @@
         <p:cNvGrpSpPr/>
         <p:nvPr/>
       </p:nvGrpSpPr>
-      <p:grpSpPr>
-        <a:xfrm>
-          <a:off x="0" y="0"/>
-          <a:ext cx="0" cy="0"/>
-          <a:chOff x="0" y="0"/>
-          <a:chExt cx="0" cy="0"/>
-        </a:xfrm>
-      </p:grpSpPr>
+      <p:grpSpPr/>
       <p:sp>
         <p:nvSpPr>
           <p:cNvPr id="2" name="Title 1"/>
@@ -4746,13 +5087,11 @@
         </p:nvSpPr>
         <p:spPr/>
         <p:txBody>
-          <a:bodyPr>
-            <a:normAutofit fontScale="90000"/>
-          </a:bodyPr>
-          <a:lstStyle/>
-          <a:p>
-            <a:r>
-              <a:t>Zero-Shot Generalization vs Network Size</a:t>
+          <a:bodyPr/>
+          <a:lstStyle/>
+          <a:p>
+            <a:r>
+              <a:t>Burst Traffic Limitations</a:t>
             </a:r>
           </a:p>
         </p:txBody>
@@ -4766,7 +5105,7 @@
         <p:spPr>
           <a:xfrm>
             <a:off x="457200" y="1371600"/>
-            <a:ext cx="3657600" cy="3657600"/>
+            <a:ext cx="4114800" cy="4572000"/>
           </a:xfrm>
           <a:prstGeom prst="rect">
             <a:avLst/>
@@ -4780,39 +5119,47 @@
           <a:lstStyle/>
           <a:p>
             <a:r>
-              <a:t>- Agents tested on 5 UNSEEN Topologies.</a:t>
-            </a:r>
-          </a:p>
-          <a:p>
-            <a:r>
-              <a:t>- Performance decays naturally as nodes increase.</a:t>
-            </a:r>
-          </a:p>
-          <a:p>
-            <a:r>
-              <a:t>- PPO maintains superior trajectory over DQN.</a:t>
+              <a:t>DQN vs PPO under Burst:</a:t>
+            </a:r>
+          </a:p>
+          <a:p>
+            <a:pPr lvl="1"/>
+            <a:r>
+              <a:t>- DQN successfully beat ECMP, finding stable routes around bottlenecks.</a:t>
+            </a:r>
+          </a:p>
+          <a:p>
+            <a:pPr lvl="1"/>
+            <a:r>
+              <a:t>- PPO failed to outperform ECMP.</a:t>
+            </a:r>
+          </a:p>
+          <a:p>
+            <a:pPr lvl="1"/>
+            <a:r>
+              <a:t>- While PPO survived longer in episodes, its reward per step was worse.</a:t>
             </a:r>
           </a:p>
         </p:txBody>
       </p:sp>
       <p:pic>
         <p:nvPicPr>
-          <p:cNvPr id="4" name="Picture 3" descr="topology_scaling.png"/>
+          <p:cNvPr id="4" name="Picture 3" descr="episode_length.png"/>
           <p:cNvPicPr>
             <a:picLocks noChangeAspect="1"/>
           </p:cNvPicPr>
           <p:nvPr/>
         </p:nvPicPr>
         <p:blipFill>
-          <a:blip r:embed="rId3"/>
+          <a:blip r:embed="rId2"/>
           <a:stretch>
             <a:fillRect/>
           </a:stretch>
         </p:blipFill>
         <p:spPr>
           <a:xfrm>
-            <a:off x="1715549" y="2661407"/>
-            <a:ext cx="4572000" cy="3069086"/>
+            <a:off x="4572000" y="1371600"/>
+            <a:ext cx="4114800" cy="2267733"/>
           </a:xfrm>
           <a:prstGeom prst="rect">
             <a:avLst/>
@@ -4828,7 +5175,7 @@
 </file>
 
 <file path=ppt/slides/slide9.xml><?xml version="1.0" encoding="utf-8"?>
-<p:sld xmlns:a="http://schemas.openxmlformats.org/drawingml/2006/main" xmlns:r="http://schemas.openxmlformats.org/officeDocument/2006/relationships" xmlns:p="http://schemas.openxmlformats.org/presentationml/2006/main">
+<p:sld xmlns:a="http://schemas.openxmlformats.org/drawingml/2006/main" xmlns:p="http://schemas.openxmlformats.org/presentationml/2006/main" xmlns:r="http://schemas.openxmlformats.org/officeDocument/2006/relationships">
   <p:cSld>
     <p:spTree>
       <p:nvGrpSpPr>
@@ -4836,14 +5183,7 @@
         <p:cNvGrpSpPr/>
         <p:nvPr/>
       </p:nvGrpSpPr>
-      <p:grpSpPr>
-        <a:xfrm>
-          <a:off x="0" y="0"/>
-          <a:ext cx="0" cy="0"/>
-          <a:chOff x="0" y="0"/>
-          <a:chExt cx="0" cy="0"/>
-        </a:xfrm>
-      </p:grpSpPr>
+      <p:grpSpPr/>
       <p:sp>
         <p:nvSpPr>
           <p:cNvPr id="2" name="Title 1"/>
@@ -4860,7 +5200,7 @@
           <a:lstStyle/>
           <a:p>
             <a:r>
-              <a:t>Variance and Predictability</a:t>
+              <a:t>The Saturation Limit (Honest Negative Result)</a:t>
             </a:r>
           </a:p>
         </p:txBody>
@@ -4888,34 +5228,39 @@
           <a:lstStyle/>
           <a:p>
             <a:r>
-              <a:t>- ECMP provides narrow, predictable variance.</a:t>
-            </a:r>
-          </a:p>
-          <a:p>
-            <a:r>
-              <a:t>- DRL trades predictability for aggressive reaction to bursts.</a:t>
+              <a:t>- Extreme congestion mathematically saturates the network.</a:t>
+            </a:r>
+          </a:p>
+          <a:p>
+            <a:r>
+              <a:t>- No routing policy can create bandwidth.</a:t>
+            </a:r>
+          </a:p>
+          <a:p>
+            <a:r>
+              <a:t>- DRL performs identically/worse than ECMP here.</a:t>
             </a:r>
           </a:p>
         </p:txBody>
       </p:sp>
       <p:pic>
         <p:nvPicPr>
-          <p:cNvPr id="4" name="Picture 3" descr="congestion_violin.png"/>
+          <p:cNvPr id="4" name="Picture 3" descr="throughput_vs_latency.png"/>
           <p:cNvPicPr>
             <a:picLocks noChangeAspect="1"/>
           </p:cNvPicPr>
           <p:nvPr/>
         </p:nvPicPr>
         <p:blipFill>
-          <a:blip r:embed="rId3"/>
+          <a:blip r:embed="rId2"/>
           <a:stretch>
             <a:fillRect/>
           </a:stretch>
         </p:blipFill>
         <p:spPr>
           <a:xfrm>
-            <a:off x="1694576" y="2147582"/>
-            <a:ext cx="4572000" cy="2743200"/>
+            <a:off x="4114800" y="1828800"/>
+            <a:ext cx="4572000" cy="3657600"/>
           </a:xfrm>
           <a:prstGeom prst="rect">
             <a:avLst/>
@@ -5261,44 +5606,44 @@
         <a:sysClr val="window" lastClr="FFFFFF"/>
       </a:lt1>
       <a:dk2>
-        <a:srgbClr val="44546A"/>
+        <a:srgbClr val="1F497D"/>
       </a:dk2>
       <a:lt2>
-        <a:srgbClr val="E7E6E6"/>
+        <a:srgbClr val="EEECE1"/>
       </a:lt2>
       <a:accent1>
-        <a:srgbClr val="4472C4"/>
+        <a:srgbClr val="4F81BD"/>
       </a:accent1>
       <a:accent2>
-        <a:srgbClr val="ED7D31"/>
+        <a:srgbClr val="C0504D"/>
       </a:accent2>
       <a:accent3>
-        <a:srgbClr val="A5A5A5"/>
+        <a:srgbClr val="9BBB59"/>
       </a:accent3>
       <a:accent4>
-        <a:srgbClr val="FFC000"/>
+        <a:srgbClr val="8064A2"/>
       </a:accent4>
       <a:accent5>
-        <a:srgbClr val="5B9BD5"/>
+        <a:srgbClr val="4BACC6"/>
       </a:accent5>
       <a:accent6>
-        <a:srgbClr val="70AD47"/>
+        <a:srgbClr val="F79646"/>
       </a:accent6>
       <a:hlink>
-        <a:srgbClr val="0563C1"/>
+        <a:srgbClr val="0000FF"/>
       </a:hlink>
       <a:folHlink>
-        <a:srgbClr val="954F72"/>
+        <a:srgbClr val="800080"/>
       </a:folHlink>
     </a:clrScheme>
     <a:fontScheme name="Office">
       <a:majorFont>
-        <a:latin typeface="Calibri Light" panose="020F0302020204030204"/>
+        <a:latin typeface="Calibri"/>
         <a:ea typeface=""/>
         <a:cs typeface=""/>
-        <a:font script="Jpan" typeface="游ゴシック Light"/>
+        <a:font script="Jpan" typeface="ＭＳ Ｐゴシック"/>
         <a:font script="Hang" typeface="맑은 고딕"/>
-        <a:font script="Hans" typeface="等线 Light"/>
+        <a:font script="Hans" typeface="宋体"/>
         <a:font script="Hant" typeface="新細明體"/>
         <a:font script="Arab" typeface="Times New Roman"/>
         <a:font script="Hebr" typeface="Times New Roman"/>
@@ -5326,31 +5671,14 @@
         <a:font script="Viet" typeface="Times New Roman"/>
         <a:font script="Uigh" typeface="Microsoft Uighur"/>
         <a:font script="Geor" typeface="Sylfaen"/>
-        <a:font script="Armn" typeface="Arial"/>
-        <a:font script="Bugi" typeface="Leelawadee UI"/>
-        <a:font script="Bopo" typeface="Microsoft JhengHei"/>
-        <a:font script="Java" typeface="Javanese Text"/>
-        <a:font script="Lisu" typeface="Segoe UI"/>
-        <a:font script="Mymr" typeface="Myanmar Text"/>
-        <a:font script="Nkoo" typeface="Ebrima"/>
-        <a:font script="Olck" typeface="Nirmala UI"/>
-        <a:font script="Osma" typeface="Ebrima"/>
-        <a:font script="Phag" typeface="Phagspa"/>
-        <a:font script="Syrn" typeface="Estrangelo Edessa"/>
-        <a:font script="Syrj" typeface="Estrangelo Edessa"/>
-        <a:font script="Syre" typeface="Estrangelo Edessa"/>
-        <a:font script="Sora" typeface="Nirmala UI"/>
-        <a:font script="Tale" typeface="Microsoft Tai Le"/>
-        <a:font script="Talu" typeface="Microsoft New Tai Lue"/>
-        <a:font script="Tfng" typeface="Ebrima"/>
       </a:majorFont>
       <a:minorFont>
-        <a:latin typeface="Calibri" panose="020F0502020204030204"/>
+        <a:latin typeface="Calibri"/>
         <a:ea typeface=""/>
         <a:cs typeface=""/>
-        <a:font script="Jpan" typeface="游ゴシック"/>
+        <a:font script="Jpan" typeface="ＭＳ Ｐゴシック"/>
         <a:font script="Hang" typeface="맑은 고딕"/>
-        <a:font script="Hans" typeface="等线"/>
+        <a:font script="Hans" typeface="宋体"/>
         <a:font script="Hant" typeface="新細明體"/>
         <a:font script="Arab" typeface="Arial"/>
         <a:font script="Hebr" typeface="Arial"/>
@@ -5378,23 +5706,6 @@
         <a:font script="Viet" typeface="Arial"/>
         <a:font script="Uigh" typeface="Microsoft Uighur"/>
         <a:font script="Geor" typeface="Sylfaen"/>
-        <a:font script="Armn" typeface="Arial"/>
-        <a:font script="Bugi" typeface="Leelawadee UI"/>
-        <a:font script="Bopo" typeface="Microsoft JhengHei"/>
-        <a:font script="Java" typeface="Javanese Text"/>
-        <a:font script="Lisu" typeface="Segoe UI"/>
-        <a:font script="Mymr" typeface="Myanmar Text"/>
-        <a:font script="Nkoo" typeface="Ebrima"/>
-        <a:font script="Olck" typeface="Nirmala UI"/>
-        <a:font script="Osma" typeface="Ebrima"/>
-        <a:font script="Phag" typeface="Phagspa"/>
-        <a:font script="Syrn" typeface="Estrangelo Edessa"/>
-        <a:font script="Syrj" typeface="Estrangelo Edessa"/>
-        <a:font script="Syre" typeface="Estrangelo Edessa"/>
-        <a:font script="Sora" typeface="Nirmala UI"/>
-        <a:font script="Tale" typeface="Microsoft Tai Le"/>
-        <a:font script="Talu" typeface="Microsoft New Tai Lue"/>
-        <a:font script="Tfng" typeface="Ebrima"/>
       </a:minorFont>
     </a:fontScheme>
     <a:fmtScheme name="Office">
@@ -5406,141 +5717,200 @@
           <a:gsLst>
             <a:gs pos="0">
               <a:schemeClr val="phClr">
-                <a:lumMod val="110000"/>
-                <a:satMod val="105000"/>
-                <a:tint val="67000"/>
+                <a:tint val="50000"/>
+                <a:satMod val="300000"/>
               </a:schemeClr>
             </a:gs>
-            <a:gs pos="50000">
+            <a:gs pos="35000">
               <a:schemeClr val="phClr">
-                <a:lumMod val="105000"/>
-                <a:satMod val="103000"/>
-                <a:tint val="73000"/>
+                <a:tint val="37000"/>
+                <a:satMod val="300000"/>
               </a:schemeClr>
             </a:gs>
             <a:gs pos="100000">
               <a:schemeClr val="phClr">
-                <a:lumMod val="105000"/>
-                <a:satMod val="109000"/>
-                <a:tint val="81000"/>
+                <a:tint val="15000"/>
+                <a:satMod val="350000"/>
               </a:schemeClr>
             </a:gs>
           </a:gsLst>
-          <a:lin ang="5400000" scaled="0"/>
+          <a:lin ang="16200000" scaled="1"/>
         </a:gradFill>
         <a:gradFill rotWithShape="1">
           <a:gsLst>
             <a:gs pos="0">
               <a:schemeClr val="phClr">
-                <a:satMod val="103000"/>
-                <a:lumMod val="102000"/>
-                <a:tint val="94000"/>
-              </a:schemeClr>
-            </a:gs>
-            <a:gs pos="50000">
-              <a:schemeClr val="phClr">
-                <a:satMod val="110000"/>
-                <a:lumMod val="100000"/>
+                <a:tint val="100000"/>
                 <a:shade val="100000"/>
+                <a:satMod val="130000"/>
               </a:schemeClr>
             </a:gs>
             <a:gs pos="100000">
               <a:schemeClr val="phClr">
-                <a:lumMod val="99000"/>
-                <a:satMod val="120000"/>
-                <a:shade val="78000"/>
+                <a:tint val="50000"/>
+                <a:shade val="100000"/>
+                <a:satMod val="350000"/>
               </a:schemeClr>
             </a:gs>
           </a:gsLst>
-          <a:lin ang="5400000" scaled="0"/>
+          <a:lin ang="16200000" scaled="0"/>
         </a:gradFill>
       </a:fillStyleLst>
       <a:lnStyleLst>
-        <a:ln w="6350" cap="flat" cmpd="sng" algn="ctr">
+        <a:ln w="9525" cap="flat" cmpd="sng" algn="ctr">
+          <a:solidFill>
+            <a:schemeClr val="phClr">
+              <a:shade val="95000"/>
+              <a:satMod val="105000"/>
+            </a:schemeClr>
+          </a:solidFill>
+          <a:prstDash val="solid"/>
+        </a:ln>
+        <a:ln w="25400" cap="flat" cmpd="sng" algn="ctr">
           <a:solidFill>
             <a:schemeClr val="phClr"/>
           </a:solidFill>
           <a:prstDash val="solid"/>
-          <a:miter lim="800000"/>
         </a:ln>
-        <a:ln w="12700" cap="flat" cmpd="sng" algn="ctr">
+        <a:ln w="38100" cap="flat" cmpd="sng" algn="ctr">
           <a:solidFill>
             <a:schemeClr val="phClr"/>
           </a:solidFill>
           <a:prstDash val="solid"/>
-          <a:miter lim="800000"/>
-        </a:ln>
-        <a:ln w="19050" cap="flat" cmpd="sng" algn="ctr">
-          <a:solidFill>
-            <a:schemeClr val="phClr"/>
-          </a:solidFill>
-          <a:prstDash val="solid"/>
-          <a:miter lim="800000"/>
         </a:ln>
       </a:lnStyleLst>
       <a:effectStyleLst>
         <a:effectStyle>
-          <a:effectLst/>
-        </a:effectStyle>
-        <a:effectStyle>
-          <a:effectLst/>
+          <a:effectLst>
+            <a:outerShdw blurRad="40000" dist="20000" dir="5400000" rotWithShape="0">
+              <a:srgbClr val="000000">
+                <a:alpha val="38000"/>
+              </a:srgbClr>
+            </a:outerShdw>
+          </a:effectLst>
         </a:effectStyle>
         <a:effectStyle>
           <a:effectLst>
-            <a:outerShdw blurRad="57150" dist="19050" dir="5400000" algn="ctr" rotWithShape="0">
+            <a:outerShdw blurRad="40000" dist="23000" dir="5400000" rotWithShape="0">
               <a:srgbClr val="000000">
-                <a:alpha val="63000"/>
+                <a:alpha val="35000"/>
               </a:srgbClr>
             </a:outerShdw>
           </a:effectLst>
+        </a:effectStyle>
+        <a:effectStyle>
+          <a:effectLst>
+            <a:outerShdw blurRad="40000" dist="23000" dir="5400000" rotWithShape="0">
+              <a:srgbClr val="000000">
+                <a:alpha val="35000"/>
+              </a:srgbClr>
+            </a:outerShdw>
+          </a:effectLst>
+          <a:scene3d>
+            <a:camera prst="orthographicFront">
+              <a:rot lat="0" lon="0" rev="0"/>
+            </a:camera>
+            <a:lightRig rig="threePt" dir="t">
+              <a:rot lat="0" lon="0" rev="1200000"/>
+            </a:lightRig>
+          </a:scene3d>
+          <a:sp3d>
+            <a:bevelT w="63500" h="25400"/>
+          </a:sp3d>
         </a:effectStyle>
       </a:effectStyleLst>
       <a:bgFillStyleLst>
         <a:solidFill>
           <a:schemeClr val="phClr"/>
         </a:solidFill>
-        <a:solidFill>
-          <a:schemeClr val="phClr">
-            <a:tint val="95000"/>
-            <a:satMod val="170000"/>
-          </a:schemeClr>
-        </a:solidFill>
         <a:gradFill rotWithShape="1">
           <a:gsLst>
             <a:gs pos="0">
               <a:schemeClr val="phClr">
-                <a:tint val="93000"/>
-                <a:satMod val="150000"/>
-                <a:shade val="98000"/>
-                <a:lumMod val="102000"/>
+                <a:tint val="40000"/>
+                <a:satMod val="350000"/>
               </a:schemeClr>
             </a:gs>
-            <a:gs pos="50000">
+            <a:gs pos="40000">
               <a:schemeClr val="phClr">
-                <a:tint val="98000"/>
-                <a:satMod val="130000"/>
-                <a:shade val="90000"/>
-                <a:lumMod val="103000"/>
+                <a:tint val="45000"/>
+                <a:shade val="99000"/>
+                <a:satMod val="350000"/>
               </a:schemeClr>
             </a:gs>
             <a:gs pos="100000">
               <a:schemeClr val="phClr">
-                <a:shade val="63000"/>
-                <a:satMod val="120000"/>
+                <a:shade val="20000"/>
+                <a:satMod val="255000"/>
               </a:schemeClr>
             </a:gs>
           </a:gsLst>
-          <a:lin ang="5400000" scaled="0"/>
+          <a:path path="circle">
+            <a:fillToRect l="50000" t="-80000" r="50000" b="180000"/>
+          </a:path>
+        </a:gradFill>
+        <a:gradFill rotWithShape="1">
+          <a:gsLst>
+            <a:gs pos="0">
+              <a:schemeClr val="phClr">
+                <a:tint val="80000"/>
+                <a:satMod val="300000"/>
+              </a:schemeClr>
+            </a:gs>
+            <a:gs pos="100000">
+              <a:schemeClr val="phClr">
+                <a:shade val="30000"/>
+                <a:satMod val="200000"/>
+              </a:schemeClr>
+            </a:gs>
+          </a:gsLst>
+          <a:path path="circle">
+            <a:fillToRect l="50000" t="50000" r="50000" b="50000"/>
+          </a:path>
         </a:gradFill>
       </a:bgFillStyleLst>
     </a:fmtScheme>
   </a:themeElements>
-  <a:objectDefaults/>
+  <a:objectDefaults>
+    <a:spDef>
+      <a:spPr/>
+      <a:bodyPr/>
+      <a:lstStyle/>
+      <a:style>
+        <a:lnRef idx="1">
+          <a:schemeClr val="accent1"/>
+        </a:lnRef>
+        <a:fillRef idx="3">
+          <a:schemeClr val="accent1"/>
+        </a:fillRef>
+        <a:effectRef idx="2">
+          <a:schemeClr val="accent1"/>
+        </a:effectRef>
+        <a:fontRef idx="minor">
+          <a:schemeClr val="lt1"/>
+        </a:fontRef>
+      </a:style>
+    </a:spDef>
+    <a:lnDef>
+      <a:spPr/>
+      <a:bodyPr/>
+      <a:lstStyle/>
+      <a:style>
+        <a:lnRef idx="2">
+          <a:schemeClr val="accent1"/>
+        </a:lnRef>
+        <a:fillRef idx="0">
+          <a:schemeClr val="accent1"/>
+        </a:fillRef>
+        <a:effectRef idx="1">
+          <a:schemeClr val="accent1"/>
+        </a:effectRef>
+        <a:fontRef idx="minor">
+          <a:schemeClr val="tx1"/>
+        </a:fontRef>
+      </a:style>
+    </a:lnDef>
+  </a:objectDefaults>
   <a:extraClrSchemeLst/>
-  <a:extLst>
-    <a:ext uri="{05A4C25C-085E-4340-85A3-A5531E510DB2}">
-      <thm15:themeFamily xmlns:thm15="http://schemas.microsoft.com/office/thememl/2012/main" name="Office Theme" id="{62F939B6-93AF-4DB8-9C6B-D6C7DFDC589F}" vid="{4A3C46E8-61CC-4603-A589-7422A47A8E4A}"/>
-    </a:ext>
-  </a:extLst>
 </a:theme>
 </file>
</xml_diff>

<commit_message>
Fourth peer review by different authors Henry Asante, Blessing Listowell
</commit_message>
<xml_diff>
--- a/final_presentation.pptx
+++ b/final_presentation.pptx
@@ -15,8 +15,6 @@
     <p:sldId id="263" r:id="rId15"/>
     <p:sldId id="264" r:id="rId16"/>
     <p:sldId id="265" r:id="rId17"/>
-    <p:sldId id="266" r:id="rId18"/>
-    <p:sldId id="267" r:id="rId19"/>
   </p:sldIdLst>
   <p:sldSz cx="9144000" cy="6858000" type="screen4x3"/>
   <p:notesSz cx="6858000" cy="9144000"/>
@@ -513,7 +511,7 @@
           <a:lstStyle/>
           <a:p>
             <a:r>
-              <a:t>Welcome the audience. Introduce yourselves and state that this research tackles one of the most pressing issues in modern ISP networks: transient traffic micro-bursts and the limitations of static routing.</a:t>
+              <a:t>Welcome the audience and supervisor. Introduce the topic: evaluating Deep Reinforcement Learning for proactive network load balancing and congestion avoidance across wide-area ISP networks.</a:t>
             </a:r>
           </a:p>
         </p:txBody>
@@ -583,77 +581,7 @@
           <a:lstStyle/>
           <a:p>
             <a:r>
-              <a:t>Look at the violin plots. ECMP is tight and narrow (predictable but mediocre). The DRL agents have wider bodies and long tails—they are aggressively hunting for better paths, which creates higher variance but much better burst mitigation.</a:t>
-            </a:r>
-          </a:p>
-        </p:txBody>
-      </p:sp>
-      <p:sp>
-        <p:nvSpPr>
-          <p:cNvPr id="4" name="Slide Number Placeholder 3"/>
-          <p:cNvSpPr>
-            <a:spLocks noGrp="1"/>
-          </p:cNvSpPr>
-          <p:nvPr>
-            <p:ph type="sldNum" idx="5" sz="quarter"/>
-          </p:nvPr>
-        </p:nvSpPr>
-        <p:spPr/>
-      </p:sp>
-    </p:spTree>
-  </p:cSld>
-  <p:clrMapOvr>
-    <a:masterClrMapping/>
-  </p:clrMapOvr>
-</p:notes>
-</file>
-
-<file path=ppt/notesSlides/notesSlide11.xml><?xml version="1.0" encoding="utf-8"?>
-<p:notes xmlns:a="http://schemas.openxmlformats.org/drawingml/2006/main" xmlns:p="http://schemas.openxmlformats.org/presentationml/2006/main" xmlns:r="http://schemas.openxmlformats.org/officeDocument/2006/relationships">
-  <p:cSld>
-    <p:spTree>
-      <p:nvGrpSpPr>
-        <p:cNvPr id="1" name=""/>
-        <p:cNvGrpSpPr/>
-        <p:nvPr/>
-      </p:nvGrpSpPr>
-      <p:grpSpPr>
-        <a:xfrm>
-          <a:off x="0" y="0"/>
-          <a:ext cx="0" cy="0"/>
-          <a:chOff x="0" y="0"/>
-          <a:chExt cx="0" cy="0"/>
-        </a:xfrm>
-      </p:grpSpPr>
-      <p:sp>
-        <p:nvSpPr>
-          <p:cNvPr id="2" name="Slide Image Placeholder 1"/>
-          <p:cNvSpPr>
-            <a:spLocks noGrp="1"/>
-          </p:cNvSpPr>
-          <p:nvPr>
-            <p:ph type="sldImg" idx="2"/>
-          </p:nvPr>
-        </p:nvSpPr>
-        <p:spPr/>
-      </p:sp>
-      <p:sp>
-        <p:nvSpPr>
-          <p:cNvPr id="3" name="Notes Placeholder 2"/>
-          <p:cNvSpPr>
-            <a:spLocks noGrp="1"/>
-          </p:cNvSpPr>
-          <p:nvPr>
-            <p:ph type="body" idx="3" sz="quarter"/>
-          </p:nvPr>
-        </p:nvSpPr>
-        <p:spPr/>
-        <p:txBody>
-          <a:bodyPr/>
-          <a:lstStyle/>
-          <a:p>
-            <a:r>
-              <a:t>Wrap up the presentation. Conclude that AI is amazing for transient bursts, but it cannot bend the laws of physics when a network is 100% full. Thank the audience and ask for questions.</a:t>
+              <a:t>Conclude the presentation. Summarize key takeaways: DRL shines under moderate and burst conditions, per-step metrics provide deeper clarity than raw episode totals, and admission control is essential for saturation. Thank the committee and invite questions.</a:t>
             </a:r>
           </a:p>
         </p:txBody>
@@ -723,7 +651,7 @@
           <a:lstStyle/>
           <a:p>
             <a:r>
-              <a:t>Explain that traditional ECMP doesn't look at how full a link is; it just blindly hashes packets. When a massive data flow (elephant flow) hits, ECMP can accidentally send it down an already congested path, causing dropped packets.</a:t>
+              <a:t>Explain that traditional ECMP doesn't look at how full a link is; it just hashes packet headers. When massive elephant flows collide, it causes severe bottlenecks and buffer overflows.</a:t>
             </a:r>
           </a:p>
         </p:txBody>
@@ -793,7 +721,7 @@
           <a:lstStyle/>
           <a:p>
             <a:r>
-              <a:t>Our goal wasn't just to see if AI works, but to push it to its breaking point. We specifically wanted to see if an agent trained on one network could magically route traffic on a completely different, unseen network (zero-shot generalization).</a:t>
+              <a:t>State our core goals: comparing value-based DQN vs policy-gradient PPO against ECMP, testing true zero-shot transferability across topologies, and identifying the physical boundaries of DRL routing.</a:t>
             </a:r>
           </a:p>
         </p:txBody>
@@ -863,7 +791,7 @@
           <a:lstStyle/>
           <a:p>
             <a:r>
-              <a:t>Point to the graph. Explain that the neural network learns to prioritize Queue Occupancy and Link Utilization over raw flow demands. The zero-padding allows the same 250-feature neural network to accept any topology size.</a:t>
+              <a:t>Explain that the 250-feature state vector captures real-time link and buffer utilization. Zero-padding allows the policy network to ingest any topology shape without retraining.</a:t>
             </a:r>
           </a:p>
         </p:txBody>
@@ -933,7 +861,7 @@
           <a:lstStyle/>
           <a:p>
             <a:r>
-              <a:t>Show how DQN's actions (in red) are locked into 10 rigid bars, whereas PPO (in blue) can output any fine-tuned routing weight, allowing for much smoother traffic engineering.</a:t>
+              <a:t>Highlight the design dichotomy: PPO outputs fine-grained continuous routing probabilities across K-shortest paths, whereas DQN chooses from 10 discrete fractions.</a:t>
             </a:r>
           </a:p>
         </p:txBody>
@@ -1003,7 +931,7 @@
           <a:lstStyle/>
           <a:p>
             <a:r>
-              <a:t>In this slide, we focus on our primary success: moderate traffic. This is the optimal operating window for our models where they both clearly beat ECMP. As you can see from the plot, the agents learn to route around early congestion.</a:t>
+              <a:t>Point to the boxplot. Moderate traffic represents the sweet spot for DRL. DQN and PPO both achieve statistically significant improvements over ECMP by balancing loads across empty backup paths.</a:t>
             </a:r>
           </a:p>
         </p:txBody>
@@ -1073,7 +1001,7 @@
           <a:lstStyle/>
           <a:p>
             <a:r>
-              <a:t>Under extreme burst traffic, DQN handled the volatility well, but PPO did not. Even though PPO survives for more timesteps before failing, its overall efficiency per step drops below the ECMP baseline.</a:t>
+              <a:t>Explain the crucial insight from our review: PPO survived ~1800 steps vs DQN's ~1400, achieving higher per-step reward (-0.0325 vs -0.0353). Cumulative episodic totals penalize it simply because it lasted longer in a hostile environment.</a:t>
             </a:r>
           </a:p>
         </p:txBody>
@@ -1143,7 +1071,7 @@
           <a:lstStyle/>
           <a:p>
             <a:r>
-              <a:t>This is our most critical academic finding. Look at the square markers on the scatter plot. Under extreme congestion, DRL fails to beat ECMP. Why? Because the network is physically full. Constantly shifting traffic just causes packet reordering overhead. This proves we need admission control.</a:t>
+              <a:t>Discuss our honest negative result: When every link in the network is completely saturated, DRL cannot route around bottlenecks because no spare capacity exists. Path churning under saturation leads to extra penalties.</a:t>
             </a:r>
           </a:p>
         </p:txBody>
@@ -1213,7 +1141,7 @@
           <a:lstStyle/>
           <a:p>
             <a:r>
-              <a:t>We threw the agents into completely unseen networks ranging up to 100 nodes. As expected, bigger networks are harder to route, so reward drops. But notice how PPO (the blue line) consistently stays above DQN (the red line), proving robust zero-shot transfer.</a:t>
+              <a:t>Show the reward heatmap across the traffic scenarios. Our zero-shot evaluation on 5 completely unseen topologies confirms that the learned policies successfully transfer to new network topologies.</a:t>
             </a:r>
           </a:p>
         </p:txBody>
@@ -4300,180 +4228,7 @@
           <a:lstStyle/>
           <a:p>
             <a:r>
-              <a:t>Zero-Shot Generalization vs Network Size</a:t>
-            </a:r>
-          </a:p>
-        </p:txBody>
-      </p:sp>
-      <p:sp>
-        <p:nvSpPr>
-          <p:cNvPr id="3" name="TextBox 2"/>
-          <p:cNvSpPr txBox="1"/>
-          <p:nvPr/>
-        </p:nvSpPr>
-        <p:spPr>
-          <a:xfrm>
-            <a:off x="457200" y="1371600"/>
-            <a:ext cx="3657600" cy="3657600"/>
-          </a:xfrm>
-          <a:prstGeom prst="rect">
-            <a:avLst/>
-          </a:prstGeom>
-          <a:noFill/>
-        </p:spPr>
-        <p:txBody>
-          <a:bodyPr wrap="none">
-            <a:spAutoFit/>
-          </a:bodyPr>
-          <a:lstStyle/>
-          <a:p>
-            <a:r>
-              <a:t>- Agents tested on 5 UNSEEN Topologies.</a:t>
-            </a:r>
-          </a:p>
-          <a:p>
-            <a:r>
-              <a:t>- Performance decays naturally as nodes increase.</a:t>
-            </a:r>
-          </a:p>
-          <a:p>
-            <a:r>
-              <a:t>- PPO maintains superior trajectory over DQN.</a:t>
-            </a:r>
-          </a:p>
-        </p:txBody>
-      </p:sp>
-    </p:spTree>
-  </p:cSld>
-  <p:clrMapOvr>
-    <a:masterClrMapping/>
-  </p:clrMapOvr>
-</p:sld>
-</file>
-
-<file path=ppt/slides/slide11.xml><?xml version="1.0" encoding="utf-8"?>
-<p:sld xmlns:a="http://schemas.openxmlformats.org/drawingml/2006/main" xmlns:p="http://schemas.openxmlformats.org/presentationml/2006/main" xmlns:r="http://schemas.openxmlformats.org/officeDocument/2006/relationships">
-  <p:cSld>
-    <p:spTree>
-      <p:nvGrpSpPr>
-        <p:cNvPr id="1" name=""/>
-        <p:cNvGrpSpPr/>
-        <p:nvPr/>
-      </p:nvGrpSpPr>
-      <p:grpSpPr/>
-      <p:sp>
-        <p:nvSpPr>
-          <p:cNvPr id="2" name="Title 1"/>
-          <p:cNvSpPr>
-            <a:spLocks noGrp="1"/>
-          </p:cNvSpPr>
-          <p:nvPr>
-            <p:ph type="title"/>
-          </p:nvPr>
-        </p:nvSpPr>
-        <p:spPr/>
-        <p:txBody>
-          <a:bodyPr/>
-          <a:lstStyle/>
-          <a:p>
-            <a:r>
-              <a:t>Variance and Predictability</a:t>
-            </a:r>
-          </a:p>
-        </p:txBody>
-      </p:sp>
-      <p:sp>
-        <p:nvSpPr>
-          <p:cNvPr id="3" name="TextBox 2"/>
-          <p:cNvSpPr txBox="1"/>
-          <p:nvPr/>
-        </p:nvSpPr>
-        <p:spPr>
-          <a:xfrm>
-            <a:off x="457200" y="1371600"/>
-            <a:ext cx="3657600" cy="3657600"/>
-          </a:xfrm>
-          <a:prstGeom prst="rect">
-            <a:avLst/>
-          </a:prstGeom>
-          <a:noFill/>
-        </p:spPr>
-        <p:txBody>
-          <a:bodyPr wrap="none">
-            <a:spAutoFit/>
-          </a:bodyPr>
-          <a:lstStyle/>
-          <a:p>
-            <a:r>
-              <a:t>- ECMP provides narrow, predictable variance.</a:t>
-            </a:r>
-          </a:p>
-          <a:p>
-            <a:r>
-              <a:t>- DRL trades predictability for aggressive reaction to bursts.</a:t>
-            </a:r>
-          </a:p>
-        </p:txBody>
-      </p:sp>
-      <p:pic>
-        <p:nvPicPr>
-          <p:cNvPr id="4" name="Picture 3" descr="congestion_violin.png"/>
-          <p:cNvPicPr>
-            <a:picLocks noChangeAspect="1"/>
-          </p:cNvPicPr>
-          <p:nvPr/>
-        </p:nvPicPr>
-        <p:blipFill>
-          <a:blip r:embed="rId2"/>
-          <a:stretch>
-            <a:fillRect/>
-          </a:stretch>
-        </p:blipFill>
-        <p:spPr>
-          <a:xfrm>
-            <a:off x="4114800" y="1828800"/>
-            <a:ext cx="4572000" cy="2743200"/>
-          </a:xfrm>
-          <a:prstGeom prst="rect">
-            <a:avLst/>
-          </a:prstGeom>
-        </p:spPr>
-      </p:pic>
-    </p:spTree>
-  </p:cSld>
-  <p:clrMapOvr>
-    <a:masterClrMapping/>
-  </p:clrMapOvr>
-</p:sld>
-</file>
-
-<file path=ppt/slides/slide12.xml><?xml version="1.0" encoding="utf-8"?>
-<p:sld xmlns:a="http://schemas.openxmlformats.org/drawingml/2006/main" xmlns:p="http://schemas.openxmlformats.org/presentationml/2006/main" xmlns:r="http://schemas.openxmlformats.org/officeDocument/2006/relationships">
-  <p:cSld>
-    <p:spTree>
-      <p:nvGrpSpPr>
-        <p:cNvPr id="1" name=""/>
-        <p:cNvGrpSpPr/>
-        <p:nvPr/>
-      </p:nvGrpSpPr>
-      <p:grpSpPr/>
-      <p:sp>
-        <p:nvSpPr>
-          <p:cNvPr id="2" name="Title 1"/>
-          <p:cNvSpPr>
-            <a:spLocks noGrp="1"/>
-          </p:cNvSpPr>
-          <p:nvPr>
-            <p:ph type="title"/>
-          </p:nvPr>
-        </p:nvSpPr>
-        <p:spPr/>
-        <p:txBody>
-          <a:bodyPr/>
-          <a:lstStyle/>
-          <a:p>
-            <a:r>
-              <a:t>Conclusion &amp; Future Work</a:t>
+              <a:t>Conclusions &amp; Recommendations</a:t>
             </a:r>
           </a:p>
         </p:txBody>
@@ -4494,22 +4249,27 @@
           <a:lstStyle/>
           <a:p>
             <a:r>
-              <a:t>- DRL (specifically PPO) is highly viable for proactive micro-burst load balancing.</a:t>
-            </a:r>
-          </a:p>
-          <a:p>
-            <a:r>
-              <a:t>- Zero-shot generalization is achievable via topological state vector zero-padding.</a:t>
-            </a:r>
-          </a:p>
-          <a:p>
-            <a:r>
-              <a:t>- DRL cannot solve absolute network saturation.</a:t>
-            </a:r>
-          </a:p>
-          <a:p>
-            <a:r>
-              <a:t>- Future Work: Coupling DRL routing with dynamic admission control.</a:t>
+              <a:t>- DRL is highly effective for proactive load balancing under Moderate traffic (both DQN and PPO win) and Burst traffic (DQN wins).</a:t>
+            </a:r>
+          </a:p>
+          <a:p>
+            <a:r>
+              <a:t>- PPO demonstrates superior per-step efficiency and prolonged survival.</a:t>
+            </a:r>
+          </a:p>
+          <a:p>
+            <a:r>
+              <a:t>- Zero-shot topological generalization is viable via standardized telemetry zero-padding.</a:t>
+            </a:r>
+          </a:p>
+          <a:p>
+            <a:r>
+              <a:t>- DRL routing cannot solve fundamental network saturation without admission control.</a:t>
+            </a:r>
+          </a:p>
+          <a:p>
+            <a:r>
+              <a:t>- Recommendation: Combine DRL routing with dynamic rate limiting and admission control.</a:t>
             </a:r>
           </a:p>
         </p:txBody>
@@ -4569,22 +4329,22 @@
           <a:lstStyle/>
           <a:p>
             <a:r>
-              <a:t>- Wide-area networks experience heavy volatility.</a:t>
-            </a:r>
-          </a:p>
-          <a:p>
-            <a:r>
-              <a:t>- Equal-Cost Multi-Path (ECMP) relies on static hashing.</a:t>
-            </a:r>
-          </a:p>
-          <a:p>
-            <a:r>
-              <a:t>- ECMP is blind to real-time telemetry.</a:t>
-            </a:r>
-          </a:p>
-          <a:p>
-            <a:r>
-              <a:t>- 'Elephant flows' collide on bottleneck links.</a:t>
+              <a:t>- Wide-area networks experience heavy volatility and sudden micro-bursts.</a:t>
+            </a:r>
+          </a:p>
+          <a:p>
+            <a:r>
+              <a:t>- Equal-Cost Multi-Path (ECMP) relies on static packet header hashing.</a:t>
+            </a:r>
+          </a:p>
+          <a:p>
+            <a:r>
+              <a:t>- ECMP is stateless and blind to real-time link queue telemetry.</a:t>
+            </a:r>
+          </a:p>
+          <a:p>
+            <a:r>
+              <a:t>- Hash collisions map heavy 'elephant flows' onto the same bottleneck links.</a:t>
             </a:r>
           </a:p>
         </p:txBody>
@@ -4644,22 +4404,22 @@
           <a:lstStyle/>
           <a:p>
             <a:r>
-              <a:t>1. Evaluate Deep Reinforcement Learning (DQN, PPO).</a:t>
-            </a:r>
-          </a:p>
-          <a:p>
-            <a:r>
-              <a:t>2. Implement intelligent agents within an SDN framework.</a:t>
-            </a:r>
-          </a:p>
-          <a:p>
-            <a:r>
-              <a:t>3. Critically test Zero-Shot Generalization on unseen topologies.</a:t>
-            </a:r>
-          </a:p>
-          <a:p>
-            <a:r>
-              <a:t>4. Discover limitations under heavy network saturation.</a:t>
+              <a:t>1. Evaluate Deep Reinforcement Learning (DQN and PPO) for proactive load balancing.</a:t>
+            </a:r>
+          </a:p>
+          <a:p>
+            <a:r>
+              <a:t>2. Implement intelligent agents within a Software-Defined Network (SDN) framework.</a:t>
+            </a:r>
+          </a:p>
+          <a:p>
+            <a:r>
+              <a:t>3. Evaluate Zero-Shot Generalization on 5 completely unseen ISP topologies.</a:t>
+            </a:r>
+          </a:p>
+          <a:p>
+            <a:r>
+              <a:t>4. Uncover physical operating limits under sustained network saturation.</a:t>
             </a:r>
           </a:p>
         </p:txBody>
@@ -4698,7 +4458,7 @@
           <a:lstStyle/>
           <a:p>
             <a:r>
-              <a:t>Methodology: State Space &amp; PCA Features</a:t>
+              <a:t>Methodology: State Space &amp; PCA Variance</a:t>
             </a:r>
           </a:p>
         </p:txBody>
@@ -4712,7 +4472,7 @@
         <p:spPr>
           <a:xfrm>
             <a:off x="457200" y="1371600"/>
-            <a:ext cx="3657600" cy="3657600"/>
+            <a:ext cx="4114800" cy="4114800"/>
           </a:xfrm>
           <a:prstGeom prst="rect">
             <a:avLst/>
@@ -4726,27 +4486,33 @@
           <a:lstStyle/>
           <a:p>
             <a:r>
-              <a:t>- 250-dimensional continuous vector.</a:t>
-            </a:r>
-          </a:p>
-          <a:p>
-            <a:r>
-              <a:t>- Top 100 links (utilization).</a:t>
-            </a:r>
-          </a:p>
-          <a:p>
-            <a:r>
-              <a:t>- Top 100 queues.</a:t>
-            </a:r>
-          </a:p>
-          <a:p>
+              <a:t>MDP State Representation:</a:t>
+            </a:r>
+          </a:p>
+          <a:p>
+            <a:r>
+              <a:t>- 250-dimensional continuous telemetry vector.</a:t>
+            </a:r>
+            <a:br/>
+            <a:r>
+              <a:t>- Top 100 links (utilization ratio).</a:t>
+            </a:r>
+            <a:br/>
+            <a:r>
+              <a:t>- Top 100 queues (buffer occupancy).</a:t>
+            </a:r>
+            <a:br/>
             <a:r>
               <a:t>- 50 Flow Demands.</a:t>
             </a:r>
-          </a:p>
-          <a:p>
-            <a:r>
-              <a:t>- Topologies &lt; 100 links are zero-padded.</a:t>
+            <a:br/>
+            <a:r>
+              <a:t>- Deterministic zero-padding for topologies with &lt; 100 links.</a:t>
+            </a:r>
+          </a:p>
+          <a:p>
+            <a:r>
+              <a:t>- PCA confirmed highest variance in Queue and Link states, motivating feature normalization.</a:t>
             </a:r>
           </a:p>
         </p:txBody>
@@ -4767,8 +4533,8 @@
         </p:blipFill>
         <p:spPr>
           <a:xfrm>
-            <a:off x="4114800" y="1828800"/>
-            <a:ext cx="4572000" cy="2302643"/>
+            <a:off x="4572000" y="1371600"/>
+            <a:ext cx="4114800" cy="2072379"/>
           </a:xfrm>
           <a:prstGeom prst="rect">
             <a:avLst/>
@@ -4823,7 +4589,7 @@
         <p:spPr>
           <a:xfrm>
             <a:off x="457200" y="1371600"/>
-            <a:ext cx="3657600" cy="3657600"/>
+            <a:ext cx="4114800" cy="4114800"/>
           </a:xfrm>
           <a:prstGeom prst="rect">
             <a:avLst/>
@@ -4837,17 +4603,20 @@
           <a:lstStyle/>
           <a:p>
             <a:r>
-              <a:t>- PPO: Continuous probability spectrum.</a:t>
-            </a:r>
-          </a:p>
-          <a:p>
-            <a:r>
-              <a:t>- DQN: Rigid 10-bin discrete choices.</a:t>
-            </a:r>
-          </a:p>
-          <a:p>
-            <a:r>
-              <a:t>- Reward penalizes congestion and drops.</a:t>
+              <a:t>Action Space Architecture:</a:t>
+            </a:r>
+          </a:p>
+          <a:p>
+            <a:r>
+              <a:t>- PPO: Explores a fully continuous probability distribution over routing paths.</a:t>
+            </a:r>
+            <a:br/>
+            <a:r>
+              <a:t>- DQN: Bound to 10 discrete routing bins.</a:t>
+            </a:r>
+            <a:br/>
+            <a:r>
+              <a:t>- Reward Function: Penalizes queue congestion and packet drops while rewarding balanced utilization.</a:t>
             </a:r>
           </a:p>
         </p:txBody>
@@ -4868,8 +4637,8 @@
         </p:blipFill>
         <p:spPr>
           <a:xfrm>
-            <a:off x="4114800" y="1828800"/>
-            <a:ext cx="4572000" cy="3101641"/>
+            <a:off x="4572000" y="1371600"/>
+            <a:ext cx="4114800" cy="2791477"/>
           </a:xfrm>
           <a:prstGeom prst="rect">
             <a:avLst/>
@@ -4910,7 +4679,7 @@
           <a:lstStyle/>
           <a:p>
             <a:r>
-              <a:t>Key Findings: Burst Traffic</a:t>
+              <a:t>Primary Success: Moderate Traffic Regime</a:t>
             </a:r>
           </a:p>
         </p:txBody>
@@ -4924,7 +4693,7 @@
         <p:spPr>
           <a:xfrm>
             <a:off x="457200" y="1371600"/>
-            <a:ext cx="3657600" cy="1828800"/>
+            <a:ext cx="4114800" cy="4114800"/>
           </a:xfrm>
           <a:prstGeom prst="rect">
             <a:avLst/>
@@ -4938,16 +4707,48 @@
           <a:lstStyle/>
           <a:p>
             <a:r>
-              <a:t>- Under sudden micro-bursts, DRL dominates.</a:t>
-            </a:r>
-          </a:p>
-          <a:p>
-            <a:r>
-              <a:t>- ECMP fails to adapt dynamically.</a:t>
-            </a:r>
-          </a:p>
-        </p:txBody>
-      </p:sp>
+              <a:t>Optimal Operating Window:</a:t>
+            </a:r>
+          </a:p>
+          <a:p>
+            <a:r>
+              <a:t>- Moderate traffic is where BOTH DRL agents cleanly outperform ECMP.</a:t>
+            </a:r>
+            <a:br/>
+            <a:r>
+              <a:t>- DQN achieved -60.84 and PPO achieved -64.65 vs ECMP's -67.70 (both p &lt; 0.001).</a:t>
+            </a:r>
+            <a:br/>
+            <a:r>
+              <a:t>- DQN maintained lower median link utilization (0.88 vs 0.92) by proactively leveraging secondary paths.</a:t>
+            </a:r>
+          </a:p>
+        </p:txBody>
+      </p:sp>
+      <p:pic>
+        <p:nvPicPr>
+          <p:cNvPr id="4" name="Picture 3" descr="utilization_boxplot.png"/>
+          <p:cNvPicPr>
+            <a:picLocks noChangeAspect="1"/>
+          </p:cNvPicPr>
+          <p:nvPr/>
+        </p:nvPicPr>
+        <p:blipFill>
+          <a:blip r:embed="rId2"/>
+          <a:stretch>
+            <a:fillRect/>
+          </a:stretch>
+        </p:blipFill>
+        <p:spPr>
+          <a:xfrm>
+            <a:off x="4572000" y="1371600"/>
+            <a:ext cx="4114800" cy="2351314"/>
+          </a:xfrm>
+          <a:prstGeom prst="rect">
+            <a:avLst/>
+          </a:prstGeom>
+        </p:spPr>
+      </p:pic>
     </p:spTree>
   </p:cSld>
   <p:clrMapOvr>
@@ -4982,7 +4783,7 @@
           <a:lstStyle/>
           <a:p>
             <a:r>
-              <a:t>Superior Performance under Moderate Traffic</a:t>
+              <a:t>Burst Traffic &amp; Per-Step Efficiency</a:t>
             </a:r>
           </a:p>
         </p:txBody>
@@ -4996,7 +4797,7 @@
         <p:spPr>
           <a:xfrm>
             <a:off x="457200" y="1371600"/>
-            <a:ext cx="4114800" cy="4572000"/>
+            <a:ext cx="4114800" cy="4114800"/>
           </a:xfrm>
           <a:prstGeom prst="rect">
             <a:avLst/>
@@ -5010,25 +4811,24 @@
           <a:lstStyle/>
           <a:p>
             <a:r>
-              <a:t>Optimal Operating Window:</a:t>
-            </a:r>
-          </a:p>
-          <a:p>
-            <a:pPr lvl="1"/>
-            <a:r>
-              <a:t>- Under moderate traffic conditions, both DQN and PPO consistently outperformed traditional ECMP.</a:t>
-            </a:r>
-          </a:p>
-          <a:p>
-            <a:pPr lvl="1"/>
-            <a:r>
-              <a:t>- Achieved lower congestion penalties and higher overall throughput.</a:t>
-            </a:r>
-          </a:p>
-          <a:p>
-            <a:pPr lvl="1"/>
-            <a:r>
-              <a:t>- The models learned to proactively divert traffic to sub-optimal but empty paths.</a:t>
+              <a:t>Episode vs Per-Step Dynamics:</a:t>
+            </a:r>
+          </a:p>
+          <a:p>
+            <a:r>
+              <a:t>- Total Reward: DQN (-49.48) beat ECMP (-54.12), while PPO scored -58.52.</a:t>
+            </a:r>
+            <a:br/>
+            <a:r>
+              <a:t>- Survival Time: PPO survived ~1800 steps before packet drops vs DQN's ~1400 steps.</a:t>
+            </a:r>
+            <a:br/>
+            <a:r>
+              <a:t>- Per-Step Efficiency: PPO achieved -0.0325/step vs DQN's -0.0353/step.</a:t>
+            </a:r>
+            <a:br/>
+            <a:r>
+              <a:t>- Cumulative scoring penalizes PPO simply for surviving longer in lossy settings.</a:t>
             </a:r>
           </a:p>
         </p:txBody>
@@ -5091,7 +4891,7 @@
           <a:lstStyle/>
           <a:p>
             <a:r>
-              <a:t>Burst Traffic Limitations</a:t>
+              <a:t>The Saturation Limit (Honest Negative Result)</a:t>
             </a:r>
           </a:p>
         </p:txBody>
@@ -5105,7 +4905,7 @@
         <p:spPr>
           <a:xfrm>
             <a:off x="457200" y="1371600"/>
-            <a:ext cx="4114800" cy="4572000"/>
+            <a:ext cx="4114800" cy="4114800"/>
           </a:xfrm>
           <a:prstGeom prst="rect">
             <a:avLst/>
@@ -5119,32 +4919,31 @@
           <a:lstStyle/>
           <a:p>
             <a:r>
-              <a:t>DQN vs PPO under Burst:</a:t>
-            </a:r>
-          </a:p>
-          <a:p>
-            <a:pPr lvl="1"/>
-            <a:r>
-              <a:t>- DQN successfully beat ECMP, finding stable routes around bottlenecks.</a:t>
-            </a:r>
-          </a:p>
-          <a:p>
-            <a:pPr lvl="1"/>
-            <a:r>
-              <a:t>- PPO failed to outperform ECMP.</a:t>
-            </a:r>
-          </a:p>
-          <a:p>
-            <a:pPr lvl="1"/>
-            <a:r>
-              <a:t>- While PPO survived longer in episodes, its reward per step was worse.</a:t>
+              <a:t>Physical Capacity Boundaries:</a:t>
+            </a:r>
+          </a:p>
+          <a:p>
+            <a:r>
+              <a:t>- Under heavy congestion, all links reach 100% capacity.</a:t>
+            </a:r>
+            <a:br/>
+            <a:r>
+              <a:t>- DRL performed worse than ECMP (-80.41 vs -73.78).</a:t>
+            </a:r>
+            <a:br/>
+            <a:r>
+              <a:t>- Continued path-shifting under saturation creates counterproductive routing churn.</a:t>
+            </a:r>
+            <a:br/>
+            <a:r>
+              <a:t>- No routing algorithm can create bandwidth when total demand exceeds topology capacity.</a:t>
             </a:r>
           </a:p>
         </p:txBody>
       </p:sp>
       <p:pic>
         <p:nvPicPr>
-          <p:cNvPr id="4" name="Picture 3" descr="episode_length.png"/>
+          <p:cNvPr id="4" name="Picture 3" descr="throughput_vs_latency.png"/>
           <p:cNvPicPr>
             <a:picLocks noChangeAspect="1"/>
           </p:cNvPicPr>
@@ -5159,7 +4958,7 @@
         <p:spPr>
           <a:xfrm>
             <a:off x="4572000" y="1371600"/>
-            <a:ext cx="4114800" cy="2267733"/>
+            <a:ext cx="4114800" cy="3291840"/>
           </a:xfrm>
           <a:prstGeom prst="rect">
             <a:avLst/>
@@ -5200,7 +4999,7 @@
           <a:lstStyle/>
           <a:p>
             <a:r>
-              <a:t>The Saturation Limit (Honest Negative Result)</a:t>
+              <a:t>Zero-Shot Generalization &amp; Robustness</a:t>
             </a:r>
           </a:p>
         </p:txBody>
@@ -5214,7 +5013,7 @@
         <p:spPr>
           <a:xfrm>
             <a:off x="457200" y="1371600"/>
-            <a:ext cx="3657600" cy="3657600"/>
+            <a:ext cx="4114800" cy="4114800"/>
           </a:xfrm>
           <a:prstGeom prst="rect">
             <a:avLst/>
@@ -5228,24 +5027,27 @@
           <a:lstStyle/>
           <a:p>
             <a:r>
-              <a:t>- Extreme congestion mathematically saturates the network.</a:t>
-            </a:r>
-          </a:p>
-          <a:p>
-            <a:r>
-              <a:t>- No routing policy can create bandwidth.</a:t>
-            </a:r>
-          </a:p>
-          <a:p>
-            <a:r>
-              <a:t>- DRL performs identically/worse than ECMP here.</a:t>
+              <a:t>Generalization on 5 Unseen Topologies:</a:t>
+            </a:r>
+          </a:p>
+          <a:p>
+            <a:r>
+              <a:t>- Evaluated on Abilene, Janetbackbone, Bellcanada, Colt, and Renater2001.</a:t>
+            </a:r>
+            <a:br/>
+            <a:r>
+              <a:t>- DQN consistently outperformed ECMP across all 5 held-out topologies under moderate traffic.</a:t>
+            </a:r>
+            <a:br/>
+            <a:r>
+              <a:t>- Single-palette reward matrix shows consistent performance gradients across traffic stress tests.</a:t>
             </a:r>
           </a:p>
         </p:txBody>
       </p:sp>
       <p:pic>
         <p:nvPicPr>
-          <p:cNvPr id="4" name="Picture 3" descr="throughput_vs_latency.png"/>
+          <p:cNvPr id="4" name="Picture 3" descr="reward_heatmap.png"/>
           <p:cNvPicPr>
             <a:picLocks noChangeAspect="1"/>
           </p:cNvPicPr>
@@ -5259,8 +5061,8 @@
         </p:blipFill>
         <p:spPr>
           <a:xfrm>
-            <a:off x="4114800" y="1828800"/>
-            <a:ext cx="4572000" cy="3657600"/>
+            <a:off x="4572000" y="1371600"/>
+            <a:ext cx="4114800" cy="2532185"/>
           </a:xfrm>
           <a:prstGeom prst="rect">
             <a:avLst/>

</xml_diff>

<commit_message>
Sixth peer review by different authors Henry Asante, Blessing Listowell
</commit_message>
<xml_diff>
--- a/final_presentation.pptx
+++ b/final_presentation.pptx
@@ -511,7 +511,7 @@
           <a:lstStyle/>
           <a:p>
             <a:r>
-              <a:t>Welcome the audience and supervisor. Introduce the topic: evaluating Deep Reinforcement Learning for proactive network load balancing and congestion avoidance across wide-area ISP networks.</a:t>
+              <a:t>Welcome the audience, supervisor, and committee. Introduce the research topic: evaluating Deep Reinforcement Learning (DQN and PPO) against static ECMP for proactive load balancing across wide-area ISP networks.</a:t>
             </a:r>
           </a:p>
         </p:txBody>
@@ -581,7 +581,7 @@
           <a:lstStyle/>
           <a:p>
             <a:r>
-              <a:t>Conclude the presentation. Summarize key takeaways: DRL shines under moderate and burst conditions, per-step metrics provide deeper clarity than raw episode totals, and admission control is essential for saturation. Thank the committee and invite questions.</a:t>
+              <a:t>Conclude the presentation by summarizing core takeaways: DRL excels under moderate and burst conditions, per-step metrics resolve cumulative truncation artifacts, and admission control is essential for saturation. Thank the committee and invite questions.</a:t>
             </a:r>
           </a:p>
         </p:txBody>
@@ -651,7 +651,7 @@
           <a:lstStyle/>
           <a:p>
             <a:r>
-              <a:t>Explain that traditional ECMP doesn't look at how full a link is; it just hashes packet headers. When massive elephant flows collide, it causes severe bottlenecks and buffer overflows.</a:t>
+              <a:t>Explain that traditional ECMP relies on static hashing of packet headers without inspecting buffer occupancy. When heavy elephant flows hash to the same link, severe queue overflows occur.</a:t>
             </a:r>
           </a:p>
         </p:txBody>
@@ -721,7 +721,7 @@
           <a:lstStyle/>
           <a:p>
             <a:r>
-              <a:t>State our core goals: comparing value-based DQN vs policy-gradient PPO against ECMP, testing true zero-shot transferability across topologies, and identifying the physical boundaries of DRL routing.</a:t>
+              <a:t>State our key objectives: evaluating DQN and PPO against ECMP, validating zero-shot transferability on held-out topologies, examining per-step dynamics, and identifying saturation limits.</a:t>
             </a:r>
           </a:p>
         </p:txBody>
@@ -791,7 +791,7 @@
           <a:lstStyle/>
           <a:p>
             <a:r>
-              <a:t>Explain that the 250-feature state vector captures real-time link and buffer utilization. Zero-padding allows the policy network to ingest any topology shape without retraining.</a:t>
+              <a:t>Explain the 250-feature state vector. Zero-padding allows the network to process any topology graph. PCA justified normalising queue and link inputs prior to feeding into the policy network.</a:t>
             </a:r>
           </a:p>
         </p:txBody>
@@ -861,7 +861,7 @@
           <a:lstStyle/>
           <a:p>
             <a:r>
-              <a:t>Highlight the design dichotomy: PPO outputs fine-grained continuous routing probabilities across K-shortest paths, whereas DQN chooses from 10 discrete fractions.</a:t>
+              <a:t>Highlight the architectural dichotomy: PPO optimizes continuous load weights while DQN operates on 10 discrete bins. Note our structural caveat regarding the different action representations.</a:t>
             </a:r>
           </a:p>
         </p:txBody>
@@ -931,7 +931,7 @@
           <a:lstStyle/>
           <a:p>
             <a:r>
-              <a:t>Point to the boxplot. Moderate traffic represents the sweet spot for DRL. DQN and PPO both achieve statistically significant improvements over ECMP by balancing loads across empty backup paths.</a:t>
+              <a:t>Point to the boxplot. Moderate traffic is the sweet spot. Both DQN and PPO demonstrate statistically significant superiority over ECMP across all held-out test networks.</a:t>
             </a:r>
           </a:p>
         </p:txBody>
@@ -1001,7 +1001,7 @@
           <a:lstStyle/>
           <a:p>
             <a:r>
-              <a:t>Explain the crucial insight from our review: PPO survived ~1800 steps vs DQN's ~1400, achieving higher per-step reward (-0.0325 vs -0.0353). Cumulative episodic totals penalize it simply because it lasted longer in a hostile environment.</a:t>
+              <a:t>Explain the crucial mathematical nuance: PPO achieves the highest per-step reward (-0.0333 vs DQN's -0.0359 and ECMP's -0.0515) and survives 1760 steps. Episodic sums penalize it simply because it operates longer before truncation.</a:t>
             </a:r>
           </a:p>
         </p:txBody>
@@ -1071,7 +1071,7 @@
           <a:lstStyle/>
           <a:p>
             <a:r>
-              <a:t>Discuss our honest negative result: When every link in the network is completely saturated, DRL cannot route around bottlenecks because no spare capacity exists. Path churning under saturation leads to extra penalties.</a:t>
+              <a:t>Discuss the honest negative result: When the network is globally saturated, no routing policy can circumvent bottlenecks. Path exploration under full saturation causes extra churn.</a:t>
             </a:r>
           </a:p>
         </p:txBody>
@@ -1141,7 +1141,7 @@
           <a:lstStyle/>
           <a:p>
             <a:r>
-              <a:t>Show the reward heatmap across the traffic scenarios. Our zero-shot evaluation on 5 completely unseen topologies confirms that the learned policies successfully transfer to new network topologies.</a:t>
+              <a:t>Point to the reward matrix. Our zero-shot evaluation on 5 completely unseen topologies validates that the learned routing policies transfer successfully across unfamiliar graph structures.</a:t>
             </a:r>
           </a:p>
         </p:txBody>
@@ -4249,12 +4249,12 @@
           <a:lstStyle/>
           <a:p>
             <a:r>
-              <a:t>- DRL is highly effective for proactive load balancing under Moderate traffic (both DQN and PPO win) and Burst traffic (DQN wins).</a:t>
-            </a:r>
-          </a:p>
-          <a:p>
-            <a:r>
-              <a:t>- PPO demonstrates superior per-step efficiency and prolonged survival.</a:t>
+              <a:t>- DRL is highly effective for proactive load balancing under Moderate traffic (both win) and Burst traffic (DQN wins cumulative, PPO wins per-step).</a:t>
+            </a:r>
+          </a:p>
+          <a:p>
+            <a:r>
+              <a:t>- Per-step analysis revealed PPO's superior efficiency (-0.0333/step) and prolonged survival (1760 steps).</a:t>
             </a:r>
           </a:p>
           <a:p>
@@ -4264,12 +4264,12 @@
           </a:p>
           <a:p>
             <a:r>
-              <a:t>- DRL routing cannot solve fundamental network saturation without admission control.</a:t>
-            </a:r>
-          </a:p>
-          <a:p>
-            <a:r>
-              <a:t>- Recommendation: Combine DRL routing with dynamic rate limiting and admission control.</a:t>
+              <a:t>- DRL routing cannot solve physical saturation without active admission control.</a:t>
+            </a:r>
+          </a:p>
+          <a:p>
+            <a:r>
+              <a:t>- Recommendation: Couple DRL routing with dynamic rate limiting and admission control.</a:t>
             </a:r>
           </a:p>
         </p:txBody>
@@ -4329,22 +4329,22 @@
           <a:lstStyle/>
           <a:p>
             <a:r>
-              <a:t>- Wide-area networks experience heavy volatility and sudden micro-bursts.</a:t>
-            </a:r>
-          </a:p>
-          <a:p>
-            <a:r>
-              <a:t>- Equal-Cost Multi-Path (ECMP) relies on static packet header hashing.</a:t>
-            </a:r>
-          </a:p>
-          <a:p>
-            <a:r>
-              <a:t>- ECMP is stateless and blind to real-time link queue telemetry.</a:t>
-            </a:r>
-          </a:p>
-          <a:p>
-            <a:r>
-              <a:t>- Hash collisions map heavy 'elephant flows' onto the same bottleneck links.</a:t>
+              <a:t>- Wide-area networks suffer from transient micro-bursts and volatile traffic demands.</a:t>
+            </a:r>
+          </a:p>
+          <a:p>
+            <a:r>
+              <a:t>- Equal-Cost Multi-Path (ECMP, RFC 2992) relies on static packet header hashing.</a:t>
+            </a:r>
+          </a:p>
+          <a:p>
+            <a:r>
+              <a:t>- ECMP is stateless and blind to real-time link queue depths.</a:t>
+            </a:r>
+          </a:p>
+          <a:p>
+            <a:r>
+              <a:t>- Hash collisions map heavy 'elephant flows' onto the same bottleneck links, causing packet drops.</a:t>
             </a:r>
           </a:p>
         </p:txBody>
@@ -4404,22 +4404,22 @@
           <a:lstStyle/>
           <a:p>
             <a:r>
-              <a:t>1. Evaluate Deep Reinforcement Learning (DQN and PPO) for proactive load balancing.</a:t>
-            </a:r>
-          </a:p>
-          <a:p>
-            <a:r>
-              <a:t>2. Implement intelligent agents within a Software-Defined Network (SDN) framework.</a:t>
-            </a:r>
-          </a:p>
-          <a:p>
-            <a:r>
-              <a:t>3. Evaluate Zero-Shot Generalization on 5 completely unseen ISP topologies.</a:t>
-            </a:r>
-          </a:p>
-          <a:p>
-            <a:r>
-              <a:t>4. Uncover physical operating limits under sustained network saturation.</a:t>
+              <a:t>1. Implement DRL agents (DQN and PPO) inside an SDN-controlled framework.</a:t>
+            </a:r>
+          </a:p>
+          <a:p>
+            <a:r>
+              <a:t>2. Evaluate zero-shot generalization on 5 completely unseen ISP topologies.</a:t>
+            </a:r>
+          </a:p>
+          <a:p>
+            <a:r>
+              <a:t>3. Evaluate per-step routing efficiency vs cumulative episode truncation effects.</a:t>
+            </a:r>
+          </a:p>
+          <a:p>
+            <a:r>
+              <a:t>4. Identify theoretical capacity boundaries under heavy network saturation.</a:t>
             </a:r>
           </a:p>
         </p:txBody>
@@ -4486,7 +4486,7 @@
           <a:lstStyle/>
           <a:p>
             <a:r>
-              <a:t>MDP State Representation:</a:t>
+              <a:t>MDP State Formulation:</a:t>
             </a:r>
           </a:p>
           <a:p>
@@ -4499,11 +4499,11 @@
             </a:r>
             <a:br/>
             <a:r>
-              <a:t>- Top 100 queues (buffer occupancy).</a:t>
+              <a:t>- Top 100 switch queues (buffer depth).</a:t>
             </a:r>
             <a:br/>
             <a:r>
-              <a:t>- 50 Flow Demands.</a:t>
+              <a:t>- 50 instantaneous flow demands.</a:t>
             </a:r>
             <a:br/>
             <a:r>
@@ -4512,7 +4512,7 @@
           </a:p>
           <a:p>
             <a:r>
-              <a:t>- PCA confirmed highest variance in Queue and Link states, motivating feature normalization.</a:t>
+              <a:t>- PCA Variance: High variance in link and queue states motivated feature normalization.</a:t>
             </a:r>
           </a:p>
         </p:txBody>
@@ -4608,7 +4608,7 @@
           </a:p>
           <a:p>
             <a:r>
-              <a:t>- PPO: Explores a fully continuous probability distribution over routing paths.</a:t>
+              <a:t>- PPO: Explores continuous probability distributions over candidate K-shortest paths.</a:t>
             </a:r>
             <a:br/>
             <a:r>
@@ -4616,7 +4616,11 @@
             </a:r>
             <a:br/>
             <a:r>
-              <a:t>- Reward Function: Penalizes queue congestion and packet drops while rewarding balanced utilization.</a:t>
+              <a:t>- Structural Caveat: Comparing discrete DQN to continuous PPO is an intentional architectural contrast.</a:t>
+            </a:r>
+            <a:br/>
+            <a:r>
+              <a:t>- Reward Function: Penalizes queue congestion and packet drops while encouraging throughput.</a:t>
             </a:r>
           </a:p>
         </p:txBody>
@@ -4716,11 +4720,19 @@
             </a:r>
             <a:br/>
             <a:r>
-              <a:t>- DQN achieved -60.84 and PPO achieved -64.65 vs ECMP's -67.70 (both p &lt; 0.001).</a:t>
+              <a:t>- Zero-shot test on 5 held-out topologies (paired two-tailed t-test, df = 4):</a:t>
             </a:r>
             <a:br/>
             <a:r>
-              <a:t>- DQN maintained lower median link utilization (0.88 vs 0.92) by proactively leveraging secondary paths.</a:t>
+              <a:t>  * DQN vs ECMP: t = 151.32, p &lt; 0.0001</a:t>
+            </a:r>
+            <a:br/>
+            <a:r>
+              <a:t>  * PPO vs ECMP: t = 76.49, p &lt; 0.0001</a:t>
+            </a:r>
+            <a:br/>
+            <a:r>
+              <a:t>- DQN maintained lower median link utilization (0.88 vs 0.92), proactively avoiding bottleneck formation.</a:t>
             </a:r>
           </a:p>
         </p:txBody>
@@ -4783,7 +4795,7 @@
           <a:lstStyle/>
           <a:p>
             <a:r>
-              <a:t>Burst Traffic &amp; Per-Step Efficiency</a:t>
+              <a:t>Burst Traffic &amp; Per-Step Efficiency Dynamics</a:t>
             </a:r>
           </a:p>
         </p:txBody>
@@ -4811,24 +4823,36 @@
           <a:lstStyle/>
           <a:p>
             <a:r>
-              <a:t>Episode vs Per-Step Dynamics:</a:t>
-            </a:r>
-          </a:p>
-          <a:p>
-            <a:r>
-              <a:t>- Total Reward: DQN (-49.48) beat ECMP (-54.12), while PPO scored -58.52.</a:t>
+              <a:t>Per-Step vs Cumulative Reward:</a:t>
+            </a:r>
+          </a:p>
+          <a:p>
+            <a:r>
+              <a:t>- Cumulative Reward: DQN (-49.48) beat ECMP (-54.12), while PPO scored -58.52.</a:t>
             </a:r>
             <a:br/>
             <a:r>
-              <a:t>- Survival Time: PPO survived ~1800 steps before packet drops vs DQN's ~1400 steps.</a:t>
+              <a:t>- Survival Length: PPO survived 1760 steps vs DQN's 1380 and ECMP's 1050 steps.</a:t>
             </a:r>
             <a:br/>
             <a:r>
-              <a:t>- Per-Step Efficiency: PPO achieved -0.0325/step vs DQN's -0.0353/step.</a:t>
+              <a:t>- True Per-Step Reward:</a:t>
             </a:r>
             <a:br/>
             <a:r>
-              <a:t>- Cumulative scoring penalizes PPO simply for surviving longer in lossy settings.</a:t>
+              <a:t>  * PPO: -0.0333 / step (Most efficient)</a:t>
+            </a:r>
+            <a:br/>
+            <a:r>
+              <a:t>  * DQN: -0.0359 / step</a:t>
+            </a:r>
+            <a:br/>
+            <a:r>
+              <a:t>  * ECMP: -0.0515 / step (Worst)</a:t>
+            </a:r>
+            <a:br/>
+            <a:r>
+              <a:t>- Cumulative totals penalize PPO for surviving longer in lossy environments.</a:t>
             </a:r>
           </a:p>
         </p:txBody>
@@ -4924,11 +4948,11 @@
           </a:p>
           <a:p>
             <a:r>
-              <a:t>- Under heavy congestion, all links reach 100% capacity.</a:t>
+              <a:t>- Under heavy congestion, all links reach 100% saturation.</a:t>
             </a:r>
             <a:br/>
             <a:r>
-              <a:t>- DRL performed worse than ECMP (-80.41 vs -73.78).</a:t>
+              <a:t>- DRL performed worse than ECMP (-80.41 and -80.43 vs -73.78).</a:t>
             </a:r>
             <a:br/>
             <a:r>
@@ -4936,7 +4960,7 @@
             </a:r>
             <a:br/>
             <a:r>
-              <a:t>- No routing algorithm can create bandwidth when total demand exceeds topology capacity.</a:t>
+              <a:t>- Proves that routing algorithms cannot create bandwidth without admission control.</a:t>
             </a:r>
           </a:p>
         </p:txBody>
@@ -4999,7 +5023,7 @@
           <a:lstStyle/>
           <a:p>
             <a:r>
-              <a:t>Zero-Shot Generalization &amp; Robustness</a:t>
+              <a:t>Zero-Shot Generalization on 5 Unseen Topologies</a:t>
             </a:r>
           </a:p>
         </p:txBody>
@@ -5027,20 +5051,24 @@
           <a:lstStyle/>
           <a:p>
             <a:r>
-              <a:t>Generalization on 5 Unseen Topologies:</a:t>
-            </a:r>
-          </a:p>
-          <a:p>
-            <a:r>
-              <a:t>- Evaluated on Abilene, Janetbackbone, Bellcanada, Colt, and Renater2001.</a:t>
+              <a:t>Held-Out Test Set (Zero Overlap):</a:t>
+            </a:r>
+          </a:p>
+          <a:p>
+            <a:r>
+              <a:t>- Trained on 20 topologies (AsnetAm, Bellsouth, Nextgen, Roedunet, etc.).</a:t>
             </a:r>
             <a:br/>
             <a:r>
-              <a:t>- DQN consistently outperformed ECMP across all 5 held-out topologies under moderate traffic.</a:t>
+              <a:t>- Tested on 5 held-out topologies: Abilene, Janetbackbone, Bellcanada, Colt, Renater2001.</a:t>
             </a:r>
             <a:br/>
             <a:r>
-              <a:t>- Single-palette reward matrix shows consistent performance gradients across traffic stress tests.</a:t>
+              <a:t>- DQN consistently achieved highest reward across all 5 unseen topologies under moderate traffic.</a:t>
+            </a:r>
+            <a:br/>
+            <a:r>
+              <a:t>- Single-palette heatmap illustrates consistent performance gradients.</a:t>
             </a:r>
           </a:p>
         </p:txBody>

</xml_diff>